<commit_message>
site: OfficeApp --slides @ 06ed9c7a for slides.starling.build
</commit_message>
<xml_diff>
--- a/examples/garden-presentation.pptx
+++ b/examples/garden-presentation.pptx
@@ -9,6 +9,11 @@
     <p:sldId id="257" r:id="rId9"/>
     <p:sldId id="258" r:id="rId10"/>
     <p:sldId id="259" r:id="rId11"/>
+    <p:sldId id="260" r:id="rId12"/>
+    <p:sldId id="261" r:id="rId13"/>
+    <p:sldId id="262" r:id="rId14"/>
+    <p:sldId id="263" r:id="rId15"/>
+    <p:sldId id="264" r:id="rId16"/>
   </p:sldIdLst>
   <p:sldSz cx="12191695" cy="6858000" type="screen4x3"/>
   <p:notesSz cx="6858000" cy="9144000"/>
@@ -202,15 +207,6 @@
         <c:majorTickMark val="out"/>
         <c:minorTickMark val="none"/>
         <c:tickLblPos val="nextTo"/>
-        <c:txPr>
-          <a:bodyPr/>
-          <a:lstStyle/>
-          <a:p>
-            <a:pPr>
-              <a:defRPr sz="1400"/>
-            </a:pPr>
-          </a:p>
-        </c:txPr>
         <c:crossAx val="-2113994440"/>
         <c:crosses val="autoZero"/>
         <c:auto val="1"/>
@@ -227,15 +223,6 @@
         <c:majorTickMark val="out"/>
         <c:minorTickMark val="none"/>
         <c:tickLblPos val="nextTo"/>
-        <c:txPr>
-          <a:bodyPr/>
-          <a:lstStyle/>
-          <a:p>
-            <a:pPr>
-              <a:defRPr sz="1200"/>
-            </a:pPr>
-          </a:p>
-        </c:txPr>
         <c:crossAx val="-2068027336"/>
         <c:crosses val="autoZero"/>
       </c:valAx>
@@ -256,6 +243,1002 @@
     <c:autoUpdate val="0"/>
   </c:externalData>
 </c:chartSpace>
+</file>
+
+<file path=ppt/charts/chart2.xml><?xml version="1.0" encoding="utf-8"?>
+<c:chartSpace xmlns:c="http://schemas.openxmlformats.org/drawingml/2006/chart" xmlns:a="http://schemas.openxmlformats.org/drawingml/2006/main" xmlns:r="http://schemas.openxmlformats.org/officeDocument/2006/relationships">
+  <c:date1904 val="0"/>
+  <c:chart>
+    <c:title>
+      <c:tx>
+        <c:rich>
+          <a:bodyPr/>
+          <a:lstStyle/>
+          <a:p>
+            <a:r>
+              <a:t>Weekly participation</a:t>
+            </a:r>
+          </a:p>
+        </c:rich>
+      </c:tx>
+      <c:layout/>
+      <c:overlay val="0"/>
+    </c:title>
+    <c:autoTitleDeleted val="0"/>
+    <c:plotArea>
+      <c:lineChart>
+        <c:grouping val="standard"/>
+        <c:varyColors val="0"/>
+        <c:ser>
+          <c:idx val="0"/>
+          <c:order val="0"/>
+          <c:tx>
+            <c:strRef>
+              <c:f>Sheet1!$B$1</c:f>
+              <c:strCache>
+                <c:ptCount val="1"/>
+                <c:pt idx="0">
+                  <c:v>Volunteer hours</c:v>
+                </c:pt>
+              </c:strCache>
+            </c:strRef>
+          </c:tx>
+          <c:spPr>
+            <a:solidFill>
+              <a:srgbClr val="DC623D"/>
+            </a:solidFill>
+          </c:spPr>
+          <c:marker>
+            <c:symbol val="none"/>
+          </c:marker>
+          <c:cat>
+            <c:strRef>
+              <c:f>Sheet1!$A$2:$A$4</c:f>
+              <c:strCache>
+                <c:ptCount val="3"/>
+                <c:pt idx="0">
+                  <c:v>Prepare</c:v>
+                </c:pt>
+                <c:pt idx="1">
+                  <c:v>Plant</c:v>
+                </c:pt>
+                <c:pt idx="2">
+                  <c:v>Grow</c:v>
+                </c:pt>
+              </c:strCache>
+            </c:strRef>
+          </c:cat>
+          <c:val>
+            <c:numRef>
+              <c:f>Sheet1!$B$2:$B$4</c:f>
+              <c:numCache>
+                <c:formatCode>General</c:formatCode>
+                <c:ptCount val="3"/>
+                <c:pt idx="0">
+                  <c:v>18</c:v>
+                </c:pt>
+                <c:pt idx="1">
+                  <c:v>32</c:v>
+                </c:pt>
+                <c:pt idx="2">
+                  <c:v>48</c:v>
+                </c:pt>
+              </c:numCache>
+            </c:numRef>
+          </c:val>
+          <c:smooth val="0"/>
+        </c:ser>
+        <c:marker val="1"/>
+        <c:smooth val="0"/>
+        <c:axId val="2118791784"/>
+        <c:axId val="2140495176"/>
+      </c:lineChart>
+      <c:catAx>
+        <c:axId val="2118791784"/>
+        <c:scaling>
+          <c:orientation val="minMax"/>
+        </c:scaling>
+        <c:delete val="0"/>
+        <c:axPos val="b"/>
+        <c:majorTickMark val="out"/>
+        <c:minorTickMark val="none"/>
+        <c:tickLblPos val="nextTo"/>
+        <c:crossAx val="2140495176"/>
+        <c:crosses val="autoZero"/>
+        <c:auto val="1"/>
+        <c:lblAlgn val="ctr"/>
+        <c:lblOffset val="100"/>
+        <c:noMultiLvlLbl val="0"/>
+      </c:catAx>
+      <c:valAx>
+        <c:axId val="2140495176"/>
+        <c:scaling/>
+        <c:delete val="0"/>
+        <c:axPos val="l"/>
+        <c:majorGridlines/>
+        <c:majorTickMark val="out"/>
+        <c:minorTickMark val="none"/>
+        <c:tickLblPos val="nextTo"/>
+        <c:crossAx val="2118791784"/>
+        <c:crosses val="autoZero"/>
+      </c:valAx>
+    </c:plotArea>
+    <c:plotVisOnly val="1"/>
+    <c:dispBlanksAs val="gap"/>
+    <c:showDLblsOverMax val="0"/>
+  </c:chart>
+  <c:txPr>
+    <a:bodyPr/>
+    <a:lstStyle/>
+    <a:p>
+      <a:pPr>
+        <a:defRPr sz="1800"/>
+      </a:pPr>
+      <a:endParaRPr lang="en-US"/>
+    </a:p>
+  </c:txPr>
+  <c:externalData r:id="rId1">
+    <c:autoUpdate val="0"/>
+  </c:externalData>
+</c:chartSpace>
+</file>
+
+<file path=ppt/charts/chart3.xml><?xml version="1.0" encoding="utf-8"?>
+<c:chartSpace xmlns:c="http://schemas.openxmlformats.org/drawingml/2006/chart" xmlns:a="http://schemas.openxmlformats.org/drawingml/2006/main" xmlns:r="http://schemas.openxmlformats.org/officeDocument/2006/relationships">
+  <c:date1904 val="0"/>
+  <c:roundedCorners val="0"/>
+  <c:chart>
+    <c:title>
+      <c:tx>
+        <c:rich>
+          <a:bodyPr/>
+          <a:lstStyle/>
+          <a:p>
+            <a:r>
+              <a:t>Cumulative harvest</a:t>
+            </a:r>
+          </a:p>
+        </c:rich>
+      </c:tx>
+      <c:layout/>
+      <c:overlay val="0"/>
+    </c:title>
+    <c:autoTitleDeleted val="0"/>
+    <c:plotArea>
+      <c:layout/>
+      <c:areaChart>
+        <c:grouping val="standard"/>
+        <c:varyColors val="0"/>
+        <c:ser>
+          <c:idx val="0"/>
+          <c:order val="0"/>
+          <c:tx>
+            <c:strRef>
+              <c:f>Sheet1!$B$1</c:f>
+              <c:strCache>
+                <c:ptCount val="1"/>
+                <c:pt idx="0">
+                  <c:v>Volunteer hours</c:v>
+                </c:pt>
+              </c:strCache>
+            </c:strRef>
+          </c:tx>
+          <c:spPr>
+            <a:solidFill>
+              <a:srgbClr val="DC623D"/>
+            </a:solidFill>
+          </c:spPr>
+          <c:cat>
+            <c:strRef>
+              <c:f>Sheet1!$A$2:$A$4</c:f>
+              <c:strCache>
+                <c:ptCount val="3"/>
+                <c:pt idx="0">
+                  <c:v>Prepare</c:v>
+                </c:pt>
+                <c:pt idx="1">
+                  <c:v>Plant</c:v>
+                </c:pt>
+                <c:pt idx="2">
+                  <c:v>Grow</c:v>
+                </c:pt>
+              </c:strCache>
+            </c:strRef>
+          </c:cat>
+          <c:val>
+            <c:numRef>
+              <c:f>Sheet1!$B$2:$B$4</c:f>
+              <c:numCache>
+                <c:formatCode>General</c:formatCode>
+                <c:ptCount val="3"/>
+                <c:pt idx="0">
+                  <c:v>18</c:v>
+                </c:pt>
+                <c:pt idx="1">
+                  <c:v>32</c:v>
+                </c:pt>
+                <c:pt idx="2">
+                  <c:v>48</c:v>
+                </c:pt>
+              </c:numCache>
+            </c:numRef>
+          </c:val>
+        </c:ser>
+        <c:dLbls>
+          <c:showLegendKey val="0"/>
+          <c:showVal val="0"/>
+          <c:showCatName val="0"/>
+          <c:showSerName val="0"/>
+          <c:showPercent val="0"/>
+          <c:showBubbleSize val="0"/>
+        </c:dLbls>
+        <c:axId val="-2101159928"/>
+        <c:axId val="-2100718248"/>
+      </c:areaChart>
+      <c:catAx>
+        <c:axId val="-2101159928"/>
+        <c:scaling>
+          <c:orientation val="minMax"/>
+        </c:scaling>
+        <c:delete val="0"/>
+        <c:axPos val="b"/>
+        <c:numFmt formatCode="General" sourceLinked="1"/>
+        <c:majorTickMark val="out"/>
+        <c:minorTickMark val="none"/>
+        <c:tickLblPos val="nextTo"/>
+        <c:crossAx val="-2100718248"/>
+        <c:crosses val="autoZero"/>
+        <c:auto val="1"/>
+        <c:lblAlgn val="ctr"/>
+        <c:lblOffset val="100"/>
+        <c:noMultiLvlLbl val="0"/>
+      </c:catAx>
+      <c:valAx>
+        <c:axId val="-2100718248"/>
+        <c:scaling>
+          <c:orientation val="minMax"/>
+        </c:scaling>
+        <c:delete val="0"/>
+        <c:axPos val="l"/>
+        <c:majorGridlines/>
+        <c:numFmt formatCode="General" sourceLinked="1"/>
+        <c:majorTickMark val="out"/>
+        <c:minorTickMark val="none"/>
+        <c:tickLblPos val="nextTo"/>
+        <c:crossAx val="-2101159928"/>
+        <c:crosses val="autoZero"/>
+        <c:crossBetween val="midCat"/>
+      </c:valAx>
+    </c:plotArea>
+    <c:plotVisOnly val="1"/>
+    <c:dispBlanksAs val="zero"/>
+    <c:showDLblsOverMax val="0"/>
+  </c:chart>
+  <c:txPr>
+    <a:bodyPr/>
+    <a:lstStyle/>
+    <a:p>
+      <a:pPr>
+        <a:defRPr sz="1800"/>
+      </a:pPr>
+      <a:endParaRPr/>
+    </a:p>
+  </c:txPr>
+  <c:externalData r:id="rId1">
+    <c:autoUpdate val="0"/>
+  </c:externalData>
+</c:chartSpace>
+</file>
+
+<file path=ppt/charts/chart4.xml><?xml version="1.0" encoding="utf-8"?>
+<c:chartSpace xmlns:c="http://schemas.openxmlformats.org/drawingml/2006/chart" xmlns:a="http://schemas.openxmlformats.org/drawingml/2006/main" xmlns:r="http://schemas.openxmlformats.org/officeDocument/2006/relationships">
+  <c:date1904 val="0"/>
+  <c:chart>
+    <c:title>
+      <c:tx>
+        <c:rich>
+          <a:bodyPr/>
+          <a:lstStyle/>
+          <a:p>
+            <a:r>
+              <a:t>Hours by activity</a:t>
+            </a:r>
+          </a:p>
+        </c:rich>
+      </c:tx>
+      <c:layout/>
+      <c:overlay val="0"/>
+    </c:title>
+    <c:autoTitleDeleted val="0"/>
+    <c:plotArea>
+      <c:barChart>
+        <c:barDir val="bar"/>
+        <c:grouping val="clustered"/>
+        <c:ser>
+          <c:idx val="0"/>
+          <c:order val="0"/>
+          <c:tx>
+            <c:strRef>
+              <c:f>Sheet1!$B$1</c:f>
+              <c:strCache>
+                <c:ptCount val="1"/>
+                <c:pt idx="0">
+                  <c:v>Volunteer hours</c:v>
+                </c:pt>
+              </c:strCache>
+            </c:strRef>
+          </c:tx>
+          <c:spPr>
+            <a:solidFill>
+              <a:srgbClr val="DC623D"/>
+            </a:solidFill>
+          </c:spPr>
+          <c:cat>
+            <c:strRef>
+              <c:f>Sheet1!$A$2:$A$4</c:f>
+              <c:strCache>
+                <c:ptCount val="3"/>
+                <c:pt idx="0">
+                  <c:v>Prepare</c:v>
+                </c:pt>
+                <c:pt idx="1">
+                  <c:v>Plant</c:v>
+                </c:pt>
+                <c:pt idx="2">
+                  <c:v>Grow</c:v>
+                </c:pt>
+              </c:strCache>
+            </c:strRef>
+          </c:cat>
+          <c:val>
+            <c:numRef>
+              <c:f>Sheet1!$B$2:$B$4</c:f>
+              <c:numCache>
+                <c:formatCode>General</c:formatCode>
+                <c:ptCount val="3"/>
+                <c:pt idx="0">
+                  <c:v>18</c:v>
+                </c:pt>
+                <c:pt idx="1">
+                  <c:v>32</c:v>
+                </c:pt>
+                <c:pt idx="2">
+                  <c:v>48</c:v>
+                </c:pt>
+              </c:numCache>
+            </c:numRef>
+          </c:val>
+        </c:ser>
+        <c:axId val="-2068027336"/>
+        <c:axId val="-2113994440"/>
+      </c:barChart>
+      <c:catAx>
+        <c:axId val="-2068027336"/>
+        <c:scaling>
+          <c:orientation val="minMax"/>
+        </c:scaling>
+        <c:delete val="0"/>
+        <c:axPos val="l"/>
+        <c:majorTickMark val="out"/>
+        <c:minorTickMark val="none"/>
+        <c:tickLblPos val="nextTo"/>
+        <c:crossAx val="-2113994440"/>
+        <c:crosses val="autoZero"/>
+        <c:auto val="1"/>
+        <c:lblAlgn val="ctr"/>
+        <c:lblOffset val="100"/>
+        <c:noMultiLvlLbl val="0"/>
+      </c:catAx>
+      <c:valAx>
+        <c:axId val="-2113994440"/>
+        <c:scaling/>
+        <c:delete val="0"/>
+        <c:axPos val="b"/>
+        <c:majorGridlines/>
+        <c:majorTickMark val="out"/>
+        <c:minorTickMark val="none"/>
+        <c:tickLblPos val="nextTo"/>
+        <c:crossAx val="-2068027336"/>
+        <c:crosses val="autoZero"/>
+      </c:valAx>
+    </c:plotArea>
+    <c:dispBlanksAs val="gap"/>
+  </c:chart>
+  <c:txPr>
+    <a:bodyPr/>
+    <a:lstStyle/>
+    <a:p>
+      <a:pPr>
+        <a:defRPr sz="1800"/>
+      </a:pPr>
+      <a:endParaRPr lang="en-US"/>
+    </a:p>
+  </c:txPr>
+  <c:externalData r:id="rId1">
+    <c:autoUpdate val="0"/>
+  </c:externalData>
+</c:chartSpace>
+</file>
+
+<file path=ppt/charts/chart5.xml><?xml version="1.0" encoding="utf-8"?>
+<c:chartSpace xmlns:c="http://schemas.openxmlformats.org/drawingml/2006/chart" xmlns:a="http://schemas.openxmlformats.org/drawingml/2006/main" xmlns:r="http://schemas.openxmlformats.org/officeDocument/2006/relationships">
+  <c:chart>
+    <c:title>
+      <c:tx>
+        <c:rich>
+          <a:bodyPr/>
+          <a:lstStyle/>
+          <a:p>
+            <a:r>
+              <a:t>Share of the work</a:t>
+            </a:r>
+          </a:p>
+        </c:rich>
+      </c:tx>
+      <c:layout/>
+      <c:overlay val="0"/>
+    </c:title>
+    <c:autoTitleDeleted val="0"/>
+    <c:plotArea>
+      <c:pieChart>
+        <c:varyColors val="1"/>
+        <c:ser>
+          <c:idx val="0"/>
+          <c:order val="0"/>
+          <c:tx>
+            <c:strRef>
+              <c:f>Sheet1!$B$1</c:f>
+              <c:strCache>
+                <c:ptCount val="1"/>
+                <c:pt idx="0">
+                  <c:v>Volunteer hours</c:v>
+                </c:pt>
+              </c:strCache>
+            </c:strRef>
+          </c:tx>
+          <c:spPr>
+            <a:solidFill>
+              <a:srgbClr val="DC623D"/>
+            </a:solidFill>
+          </c:spPr>
+          <c:cat>
+            <c:strRef>
+              <c:f>Sheet1!$A$2:$A$4</c:f>
+              <c:strCache>
+                <c:ptCount val="3"/>
+                <c:pt idx="0">
+                  <c:v>Prepare</c:v>
+                </c:pt>
+                <c:pt idx="1">
+                  <c:v>Plant</c:v>
+                </c:pt>
+                <c:pt idx="2">
+                  <c:v>Grow</c:v>
+                </c:pt>
+              </c:strCache>
+            </c:strRef>
+          </c:cat>
+          <c:val>
+            <c:numRef>
+              <c:f>Sheet1!$B$2:$B$4</c:f>
+              <c:numCache>
+                <c:formatCode>General</c:formatCode>
+                <c:ptCount val="3"/>
+                <c:pt idx="0">
+                  <c:v>18</c:v>
+                </c:pt>
+                <c:pt idx="1">
+                  <c:v>32</c:v>
+                </c:pt>
+                <c:pt idx="2">
+                  <c:v>48</c:v>
+                </c:pt>
+              </c:numCache>
+            </c:numRef>
+          </c:val>
+        </c:ser>
+      </c:pieChart>
+    </c:plotArea>
+    <c:dispBlanksAs val="gap"/>
+  </c:chart>
+  <c:txPr>
+    <a:bodyPr/>
+    <a:lstStyle/>
+    <a:p>
+      <a:pPr>
+        <a:defRPr sz="1800"/>
+      </a:pPr>
+      <a:endParaRPr lang="en-US"/>
+    </a:p>
+  </c:txPr>
+  <c:externalData r:id="rId1">
+    <c:autoUpdate val="0"/>
+  </c:externalData>
+</c:chartSpace>
+</file>
+
+<file path=ppt/charts/chart6.xml><?xml version="1.0" encoding="utf-8"?>
+<c:chartSpace xmlns:c="http://schemas.openxmlformats.org/drawingml/2006/chart" xmlns:a="http://schemas.openxmlformats.org/drawingml/2006/main" xmlns:r="http://schemas.openxmlformats.org/officeDocument/2006/relationships">
+  <c:chart>
+    <c:title>
+      <c:tx>
+        <c:rich>
+          <a:bodyPr/>
+          <a:lstStyle/>
+          <a:p>
+            <a:r>
+              <a:t>Watering time and harvest</a:t>
+            </a:r>
+          </a:p>
+        </c:rich>
+      </c:tx>
+      <c:layout/>
+      <c:overlay val="0"/>
+    </c:title>
+    <c:plotArea>
+      <c:scatterChart>
+        <c:scatterStyle val="lineMarker"/>
+        <c:varyColors val="0"/>
+        <c:ser>
+          <c:idx val="0"/>
+          <c:order val="0"/>
+          <c:tx>
+            <c:strRef>
+              <c:f>Sheet1!$B$1</c:f>
+              <c:strCache>
+                <c:ptCount val="1"/>
+                <c:pt idx="0">
+                  <c:v>Beds</c:v>
+                </c:pt>
+              </c:strCache>
+            </c:strRef>
+          </c:tx>
+          <c:spPr>
+            <a:ln w="47625">
+              <a:noFill/>
+            </a:ln>
+          </c:spPr>
+          <c:xVal>
+            <c:numRef>
+              <c:f>Sheet1!$A$2:$A$6</c:f>
+              <c:numCache>
+                <c:formatCode>General</c:formatCode>
+                <c:ptCount val="5"/>
+                <c:pt idx="0">
+                  <c:v>2</c:v>
+                </c:pt>
+                <c:pt idx="1">
+                  <c:v>4</c:v>
+                </c:pt>
+                <c:pt idx="2">
+                  <c:v>6</c:v>
+                </c:pt>
+                <c:pt idx="3">
+                  <c:v>8</c:v>
+                </c:pt>
+                <c:pt idx="4">
+                  <c:v>10</c:v>
+                </c:pt>
+              </c:numCache>
+            </c:numRef>
+          </c:xVal>
+          <c:yVal>
+            <c:numRef>
+              <c:f>Sheet1!$B$2:$B$6</c:f>
+              <c:numCache>
+                <c:formatCode>General</c:formatCode>
+                <c:ptCount val="5"/>
+                <c:pt idx="0">
+                  <c:v>5</c:v>
+                </c:pt>
+                <c:pt idx="1">
+                  <c:v>12</c:v>
+                </c:pt>
+                <c:pt idx="2">
+                  <c:v>18</c:v>
+                </c:pt>
+                <c:pt idx="3">
+                  <c:v>25</c:v>
+                </c:pt>
+                <c:pt idx="4">
+                  <c:v>29</c:v>
+                </c:pt>
+              </c:numCache>
+            </c:numRef>
+          </c:yVal>
+          <c:smooth val="0"/>
+        </c:ser>
+        <c:axId val="-2128940872"/>
+        <c:axId val="-2129643912"/>
+      </c:scatterChart>
+      <c:valAx>
+        <c:axId val="-2128940872"/>
+        <c:scaling>
+          <c:orientation val="minMax"/>
+        </c:scaling>
+        <c:delete val="0"/>
+        <c:axPos val="b"/>
+        <c:numFmt formatCode="General" sourceLinked="1"/>
+        <c:majorTickMark val="out"/>
+        <c:minorTickMark val="none"/>
+        <c:tickLblPos val="nextTo"/>
+        <c:crossAx val="-2129643912"/>
+        <c:crosses val="autoZero"/>
+        <c:crossBetween val="midCat"/>
+      </c:valAx>
+      <c:valAx>
+        <c:axId val="-2129643912"/>
+        <c:scaling>
+          <c:orientation val="minMax"/>
+        </c:scaling>
+        <c:delete val="0"/>
+        <c:axPos val="l"/>
+        <c:majorGridlines/>
+        <c:numFmt formatCode="General" sourceLinked="1"/>
+        <c:majorTickMark val="out"/>
+        <c:minorTickMark val="none"/>
+        <c:tickLblPos val="nextTo"/>
+        <c:crossAx val="-2128940872"/>
+        <c:crosses val="autoZero"/>
+        <c:crossBetween val="midCat"/>
+      </c:valAx>
+    </c:plotArea>
+    <c:plotVisOnly val="1"/>
+    <c:dispBlanksAs val="gap"/>
+    <c:showDLblsOverMax val="0"/>
+  </c:chart>
+  <c:txPr>
+    <a:bodyPr/>
+    <a:lstStyle/>
+    <a:p>
+      <a:pPr>
+        <a:defRPr sz="1800"/>
+      </a:pPr>
+      <a:endParaRPr lang="en-US"/>
+    </a:p>
+  </c:txPr>
+  <c:externalData r:id="rId1">
+    <c:autoUpdate val="0"/>
+  </c:externalData>
+</c:chartSpace>
+</file>
+
+<file path=ppt/charts/chart7.xml><?xml version="1.0" encoding="utf-8"?>
+<c:chartSpace xmlns:c="http://schemas.openxmlformats.org/drawingml/2006/chart" xmlns:a="http://schemas.openxmlformats.org/drawingml/2006/main" xmlns:r="http://schemas.openxmlformats.org/officeDocument/2006/relationships">
+  <c:date1904 val="0"/>
+  <c:roundedCorners val="0"/>
+  <c:chart>
+    <c:title>
+      <c:tx>
+        <c:rich>
+          <a:bodyPr/>
+          <a:lstStyle/>
+          <a:p>
+            <a:r>
+              <a:t>Where the time goes</a:t>
+            </a:r>
+          </a:p>
+        </c:rich>
+      </c:tx>
+      <c:layout/>
+      <c:overlay val="0"/>
+    </c:title>
+    <c:autoTitleDeleted val="0"/>
+    <c:plotArea>
+      <c:layout/>
+      <c:doughnutChart>
+        <c:varyColors val="1"/>
+        <c:ser>
+          <c:idx val="0"/>
+          <c:order val="0"/>
+          <c:tx>
+            <c:strRef>
+              <c:f>Sheet1!$B$1</c:f>
+              <c:strCache>
+                <c:ptCount val="1"/>
+                <c:pt idx="0">
+                  <c:v>Volunteer hours</c:v>
+                </c:pt>
+              </c:strCache>
+            </c:strRef>
+          </c:tx>
+          <c:spPr>
+            <a:solidFill>
+              <a:srgbClr val="DC623D"/>
+            </a:solidFill>
+          </c:spPr>
+          <c:cat>
+            <c:strRef>
+              <c:f>Sheet1!$A$2:$A$4</c:f>
+              <c:strCache>
+                <c:ptCount val="3"/>
+                <c:pt idx="0">
+                  <c:v>Prepare</c:v>
+                </c:pt>
+                <c:pt idx="1">
+                  <c:v>Plant</c:v>
+                </c:pt>
+                <c:pt idx="2">
+                  <c:v>Grow</c:v>
+                </c:pt>
+              </c:strCache>
+            </c:strRef>
+          </c:cat>
+          <c:val>
+            <c:numRef>
+              <c:f>Sheet1!$B$2:$B$4</c:f>
+              <c:numCache>
+                <c:formatCode>General</c:formatCode>
+                <c:ptCount val="3"/>
+                <c:pt idx="0">
+                  <c:v>18</c:v>
+                </c:pt>
+                <c:pt idx="1">
+                  <c:v>32</c:v>
+                </c:pt>
+                <c:pt idx="2">
+                  <c:v>48</c:v>
+                </c:pt>
+              </c:numCache>
+            </c:numRef>
+          </c:val>
+        </c:ser>
+        <c:dLbls>
+          <c:showLegendKey val="0"/>
+          <c:showVal val="0"/>
+          <c:showCatName val="0"/>
+          <c:showSerName val="0"/>
+          <c:showPercent val="0"/>
+          <c:showBubbleSize val="0"/>
+          <c:showLeaderLines val="1"/>
+        </c:dLbls>
+        <c:firstSliceAng val="0"/>
+        <c:holeSize val="50"/>
+      </c:doughnutChart>
+    </c:plotArea>
+    <c:plotVisOnly val="1"/>
+    <c:dispBlanksAs val="gap"/>
+    <c:showDLblsOverMax val="0"/>
+  </c:chart>
+  <c:txPr>
+    <a:bodyPr/>
+    <a:lstStyle/>
+    <a:p>
+      <a:pPr>
+        <a:defRPr sz="1800"/>
+      </a:pPr>
+      <a:endParaRPr/>
+    </a:p>
+  </c:txPr>
+  <c:externalData r:id="rId1">
+    <c:autoUpdate val="0"/>
+  </c:externalData>
+</c:chartSpace>
+</file>
+
+<file path=ppt/diagrams/colors1.xml><?xml version="1.0" encoding="utf-8"?>
+<dgm:colorsDef xmlns:dgm="http://schemas.openxmlformats.org/drawingml/2006/diagram" uniqueId="urn:starling:garden:colors" minVer="12.0">
+  <dgm:title val="Garden"/>
+  <dgm:desc val=""/>
+  <dgm:catLst/>
+</dgm:colorsDef>
+</file>
+
+<file path=ppt/diagrams/data1.xml><?xml version="1.0" encoding="utf-8"?>
+<dgm:dataModel xmlns:dgm="http://schemas.openxmlformats.org/drawingml/2006/diagram" xmlns:a="http://schemas.openxmlformats.org/drawingml/2006/main" xmlns:dsp="http://schemas.microsoft.com/office/drawing/2008/diagram">
+  <dgm:ptLst>
+    <dgm:pt modelId="0" type="doc">
+      <dgm:prSet/>
+    </dgm:pt>
+    <dgm:pt modelId="1">
+      <dgm:prSet/>
+      <dgm:spPr/>
+      <dgm:t>
+        <a:bodyPr/>
+        <a:lstStyle/>
+        <a:p>
+          <a:r>
+            <a:t>Learn</a:t>
+          </a:r>
+        </a:p>
+      </dgm:t>
+    </dgm:pt>
+    <dgm:pt modelId="2">
+      <dgm:prSet/>
+      <dgm:spPr/>
+      <dgm:t>
+        <a:bodyPr/>
+        <a:lstStyle/>
+        <a:p>
+          <a:r>
+            <a:t>Share</a:t>
+          </a:r>
+        </a:p>
+      </dgm:t>
+    </dgm:pt>
+    <dgm:pt modelId="3">
+      <dgm:prSet/>
+      <dgm:spPr/>
+      <dgm:t>
+        <a:bodyPr/>
+        <a:lstStyle/>
+        <a:p>
+          <a:r>
+            <a:t>Grow</a:t>
+          </a:r>
+        </a:p>
+      </dgm:t>
+    </dgm:pt>
+  </dgm:ptLst>
+  <dgm:cxnLst>
+    <dgm:cxn modelId="11" type="parOf" srcId="0" destId="1" srcOrd="0" destOrd="0"/>
+    <dgm:cxn modelId="12" type="parOf" srcId="0" destId="2" srcOrd="1" destOrd="0"/>
+    <dgm:cxn modelId="13" type="parOf" srcId="0" destId="3" srcOrd="2" destOrd="0"/>
+  </dgm:cxnLst>
+  <dgm:bg/>
+  <dgm:whole/>
+  <dgm:extLst>
+    <a:ext uri="http://schemas.microsoft.com/office/drawing/2008/diagram">
+      <dsp:dataModelExt relId="rIdGardenDrawing" minVer="http://schemas.openxmlformats.org/drawingml/2006/diagram"/>
+    </a:ext>
+  </dgm:extLst>
+</dgm:dataModel>
+</file>
+
+<file path=ppt/diagrams/drawing1.xml><?xml version="1.0" encoding="utf-8"?>
+<dsp:drawing xmlns:dsp="http://schemas.microsoft.com/office/drawing/2008/diagram" xmlns:a="http://schemas.openxmlformats.org/drawingml/2006/main">
+  <dsp:spTree>
+    <dsp:nvGrpSpPr>
+      <dsp:cNvPr id="1" name=""/>
+      <dsp:cNvGrpSpPr/>
+      <dsp:nvPr/>
+    </dsp:nvGrpSpPr>
+    <dsp:grpSpPr>
+      <a:xfrm>
+        <a:off x="0" y="0"/>
+        <a:ext cx="10400000" cy="2000000"/>
+        <a:chOff x="0" y="0"/>
+        <a:chExt cx="10400000" cy="2000000"/>
+      </a:xfrm>
+    </dsp:grpSpPr>
+    <dsp:sp modelId="1">
+      <dsp:nvSpPr>
+        <dsp:cNvPr id="2" name="Learn"/>
+        <dsp:cNvSpPr/>
+        <dsp:nvPr/>
+      </dsp:nvSpPr>
+      <dsp:spPr>
+        <a:xfrm>
+          <a:off x="0" y="0"/>
+          <a:ext cx="3200000" cy="2000000"/>
+        </a:xfrm>
+        <a:prstGeom prst="chevron">
+          <a:avLst/>
+        </a:prstGeom>
+        <a:solidFill>
+          <a:srgbClr val="2449DF"/>
+        </a:solidFill>
+        <a:ln>
+          <a:noFill/>
+        </a:ln>
+      </dsp:spPr>
+      <dsp:txBody>
+        <a:bodyPr anchor="ctr"/>
+        <a:lstStyle/>
+        <a:p>
+          <a:pPr algn="ctr"/>
+          <a:r>
+            <a:rPr sz="3000">
+              <a:solidFill>
+                <a:srgbClr val="FFFFFF"/>
+              </a:solidFill>
+            </a:rPr>
+            <a:t>Learn</a:t>
+          </a:r>
+        </a:p>
+      </dsp:txBody>
+    </dsp:sp>
+    <dsp:sp modelId="2">
+      <dsp:nvSpPr>
+        <dsp:cNvPr id="3" name="Share"/>
+        <dsp:cNvSpPr/>
+        <dsp:nvPr/>
+      </dsp:nvSpPr>
+      <dsp:spPr>
+        <a:xfrm>
+          <a:off x="3600000" y="0"/>
+          <a:ext cx="3200000" cy="2000000"/>
+        </a:xfrm>
+        <a:prstGeom prst="chevron">
+          <a:avLst/>
+        </a:prstGeom>
+        <a:solidFill>
+          <a:srgbClr val="17644F"/>
+        </a:solidFill>
+        <a:ln>
+          <a:noFill/>
+        </a:ln>
+      </dsp:spPr>
+      <dsp:txBody>
+        <a:bodyPr anchor="ctr"/>
+        <a:lstStyle/>
+        <a:p>
+          <a:pPr algn="ctr"/>
+          <a:r>
+            <a:rPr sz="3000">
+              <a:solidFill>
+                <a:srgbClr val="FFFFFF"/>
+              </a:solidFill>
+            </a:rPr>
+            <a:t>Share</a:t>
+          </a:r>
+        </a:p>
+      </dsp:txBody>
+    </dsp:sp>
+    <dsp:sp modelId="3">
+      <dsp:nvSpPr>
+        <dsp:cNvPr id="4" name="Grow"/>
+        <dsp:cNvSpPr/>
+        <dsp:nvPr/>
+      </dsp:nvSpPr>
+      <dsp:spPr>
+        <a:xfrm>
+          <a:off x="7200000" y="0"/>
+          <a:ext cx="3200000" cy="2000000"/>
+        </a:xfrm>
+        <a:prstGeom prst="chevron">
+          <a:avLst/>
+        </a:prstGeom>
+        <a:solidFill>
+          <a:srgbClr val="AC4328"/>
+        </a:solidFill>
+        <a:ln>
+          <a:noFill/>
+        </a:ln>
+      </dsp:spPr>
+      <dsp:txBody>
+        <a:bodyPr anchor="ctr"/>
+        <a:lstStyle/>
+        <a:p>
+          <a:pPr algn="ctr"/>
+          <a:r>
+            <a:rPr sz="3000">
+              <a:solidFill>
+                <a:srgbClr val="FFFFFF"/>
+              </a:solidFill>
+            </a:rPr>
+            <a:t>Grow</a:t>
+          </a:r>
+        </a:p>
+      </dsp:txBody>
+    </dsp:sp>
+  </dsp:spTree>
+</dsp:drawing>
+</file>
+
+<file path=ppt/diagrams/layout1.xml><?xml version="1.0" encoding="utf-8"?>
+<dgm:layoutDef xmlns:dgm="http://schemas.openxmlformats.org/drawingml/2006/diagram" uniqueId="urn:starling:garden:process" minVer="12.0">
+  <dgm:title val="Garden process"/>
+  <dgm:desc val="Learn, share, grow"/>
+  <dgm:catLst/>
+  <dgm:layoutNode name="process">
+    <dgm:alg type="lin"/>
+    <dgm:forEach name="nodes" axis="ch" ptType="node">
+      <dgm:layoutNode name="node">
+        <dgm:alg type="tx"/>
+        <dgm:shape type="chevron"/>
+      </dgm:layoutNode>
+    </dgm:forEach>
+  </dgm:layoutNode>
+</dgm:layoutDef>
+</file>
+
+<file path=ppt/diagrams/quickStyle1.xml><?xml version="1.0" encoding="utf-8"?>
+<dgm:styleDef xmlns:dgm="http://schemas.openxmlformats.org/drawingml/2006/diagram" uniqueId="urn:starling:garden:style" minVer="12.0">
+  <dgm:title val="Garden"/>
+  <dgm:desc val=""/>
+  <dgm:catLst/>
+</dgm:styleDef>
 </file>
 
 <file path=ppt/notesMasters/notesMaster1.xml><?xml version="1.0" encoding="utf-8"?>
@@ -653,7 +1636,567 @@
           <a:lstStyle/>
           <a:p>
             <a:r>
-              <a:t>Introduce the garden: six beds, a four-week opening plan, and room for everyone. These are illustrative planning figures.</a:t>
+              <a:t>Try it: edit the chart data. Start Slide Show to present; open Presenter View for notes. These are fictional planning figures. Invite the audience to change the plan.</a:t>
+            </a:r>
+          </a:p>
+        </p:txBody>
+      </p:sp>
+      <p:sp>
+        <p:nvSpPr>
+          <p:cNvPr id="4" name="Slide Number Placeholder 3"/>
+          <p:cNvSpPr>
+            <a:spLocks noGrp="1"/>
+          </p:cNvSpPr>
+          <p:nvPr>
+            <p:ph type="sldNum" idx="5" sz="quarter"/>
+          </p:nvPr>
+        </p:nvSpPr>
+        <p:spPr/>
+      </p:sp>
+    </p:spTree>
+  </p:cSld>
+  <p:clrMapOvr>
+    <a:masterClrMapping/>
+  </p:clrMapOvr>
+</p:notes>
+</file>
+
+<file path=ppt/notesSlides/notesSlide2.xml><?xml version="1.0" encoding="utf-8"?>
+<p:notes xmlns:a="http://schemas.openxmlformats.org/drawingml/2006/main" xmlns:p="http://schemas.openxmlformats.org/presentationml/2006/main" xmlns:r="http://schemas.openxmlformats.org/officeDocument/2006/relationships">
+  <p:cSld>
+    <p:spTree>
+      <p:nvGrpSpPr>
+        <p:cNvPr id="1" name=""/>
+        <p:cNvGrpSpPr/>
+        <p:nvPr/>
+      </p:nvGrpSpPr>
+      <p:grpSpPr>
+        <a:xfrm>
+          <a:off x="0" y="0"/>
+          <a:ext cx="0" cy="0"/>
+          <a:chOff x="0" y="0"/>
+          <a:chExt cx="0" cy="0"/>
+        </a:xfrm>
+      </p:grpSpPr>
+      <p:sp>
+        <p:nvSpPr>
+          <p:cNvPr id="2" name="Slide Image Placeholder 1"/>
+          <p:cNvSpPr>
+            <a:spLocks noGrp="1"/>
+          </p:cNvSpPr>
+          <p:nvPr>
+            <p:ph type="sldImg" idx="2"/>
+          </p:nvPr>
+        </p:nvSpPr>
+        <p:spPr/>
+      </p:sp>
+      <p:sp>
+        <p:nvSpPr>
+          <p:cNvPr id="3" name="Notes Placeholder 2"/>
+          <p:cNvSpPr>
+            <a:spLocks noGrp="1"/>
+          </p:cNvSpPr>
+          <p:nvPr>
+            <p:ph type="body" idx="3" sz="quarter"/>
+          </p:nvPr>
+        </p:nvSpPr>
+        <p:spPr/>
+        <p:txBody>
+          <a:bodyPr/>
+          <a:lstStyle/>
+          <a:p>
+            <a:r>
+              <a:t>Try it: move or resize the picture, edit the caption, and add a link to the text. These are fictional planning figures. Invite the audience to change the plan.</a:t>
+            </a:r>
+          </a:p>
+        </p:txBody>
+      </p:sp>
+      <p:sp>
+        <p:nvSpPr>
+          <p:cNvPr id="4" name="Slide Number Placeholder 3"/>
+          <p:cNvSpPr>
+            <a:spLocks noGrp="1"/>
+          </p:cNvSpPr>
+          <p:nvPr>
+            <p:ph type="sldNum" idx="5" sz="quarter"/>
+          </p:nvPr>
+        </p:nvSpPr>
+        <p:spPr/>
+      </p:sp>
+    </p:spTree>
+  </p:cSld>
+  <p:clrMapOvr>
+    <a:masterClrMapping/>
+  </p:clrMapOvr>
+</p:notes>
+</file>
+
+<file path=ppt/notesSlides/notesSlide3.xml><?xml version="1.0" encoding="utf-8"?>
+<p:notes xmlns:a="http://schemas.openxmlformats.org/drawingml/2006/main" xmlns:p="http://schemas.openxmlformats.org/presentationml/2006/main" xmlns:r="http://schemas.openxmlformats.org/officeDocument/2006/relationships">
+  <p:cSld>
+    <p:spTree>
+      <p:nvGrpSpPr>
+        <p:cNvPr id="1" name=""/>
+        <p:cNvGrpSpPr/>
+        <p:nvPr/>
+      </p:nvGrpSpPr>
+      <p:grpSpPr>
+        <a:xfrm>
+          <a:off x="0" y="0"/>
+          <a:ext cx="0" cy="0"/>
+          <a:chOff x="0" y="0"/>
+          <a:chExt cx="0" cy="0"/>
+        </a:xfrm>
+      </p:grpSpPr>
+      <p:sp>
+        <p:nvSpPr>
+          <p:cNvPr id="2" name="Slide Image Placeholder 1"/>
+          <p:cNvSpPr>
+            <a:spLocks noGrp="1"/>
+          </p:cNvSpPr>
+          <p:nvPr>
+            <p:ph type="sldImg" idx="2"/>
+          </p:nvPr>
+        </p:nvSpPr>
+        <p:spPr/>
+      </p:sp>
+      <p:sp>
+        <p:nvSpPr>
+          <p:cNvPr id="3" name="Notes Placeholder 2"/>
+          <p:cNvSpPr>
+            <a:spLocks noGrp="1"/>
+          </p:cNvSpPr>
+          <p:nvPr>
+            <p:ph type="body" idx="3" sz="quarter"/>
+          </p:nvPr>
+        </p:nvSpPr>
+        <p:spPr/>
+        <p:txBody>
+          <a:bodyPr/>
+          <a:lstStyle/>
+          <a:p>
+            <a:r>
+              <a:t>Try it: edit and align the shapes. In Slide Show, click to reveal the final step with a wipe. These are fictional planning figures. Invite the audience to change the plan.</a:t>
+            </a:r>
+          </a:p>
+        </p:txBody>
+      </p:sp>
+      <p:sp>
+        <p:nvSpPr>
+          <p:cNvPr id="4" name="Slide Number Placeholder 3"/>
+          <p:cNvSpPr>
+            <a:spLocks noGrp="1"/>
+          </p:cNvSpPr>
+          <p:nvPr>
+            <p:ph type="sldNum" idx="5" sz="quarter"/>
+          </p:nvPr>
+        </p:nvSpPr>
+        <p:spPr/>
+      </p:sp>
+    </p:spTree>
+  </p:cSld>
+  <p:clrMapOvr>
+    <a:masterClrMapping/>
+  </p:clrMapOvr>
+</p:notes>
+</file>
+
+<file path=ppt/notesSlides/notesSlide4.xml><?xml version="1.0" encoding="utf-8"?>
+<p:notes xmlns:a="http://schemas.openxmlformats.org/drawingml/2006/main" xmlns:p="http://schemas.openxmlformats.org/presentationml/2006/main" xmlns:r="http://schemas.openxmlformats.org/officeDocument/2006/relationships">
+  <p:cSld>
+    <p:spTree>
+      <p:nvGrpSpPr>
+        <p:cNvPr id="1" name=""/>
+        <p:cNvGrpSpPr/>
+        <p:nvPr/>
+      </p:nvGrpSpPr>
+      <p:grpSpPr>
+        <a:xfrm>
+          <a:off x="0" y="0"/>
+          <a:ext cx="0" cy="0"/>
+          <a:chOff x="0" y="0"/>
+          <a:chExt cx="0" cy="0"/>
+        </a:xfrm>
+      </p:grpSpPr>
+      <p:sp>
+        <p:nvSpPr>
+          <p:cNvPr id="2" name="Slide Image Placeholder 1"/>
+          <p:cNvSpPr>
+            <a:spLocks noGrp="1"/>
+          </p:cNvSpPr>
+          <p:nvPr>
+            <p:ph type="sldImg" idx="2"/>
+          </p:nvPr>
+        </p:nvSpPr>
+        <p:spPr/>
+      </p:sp>
+      <p:sp>
+        <p:nvSpPr>
+          <p:cNvPr id="3" name="Notes Placeholder 2"/>
+          <p:cNvSpPr>
+            <a:spLocks noGrp="1"/>
+          </p:cNvSpPr>
+          <p:nvPr>
+            <p:ph type="body" idx="3" sz="quarter"/>
+          </p:nvPr>
+        </p:nvSpPr>
+        <p:spPr/>
+        <p:txBody>
+          <a:bodyPr/>
+          <a:lstStyle/>
+          <a:p>
+            <a:r>
+              <a:t>Try it: edit table cells, change fills, and adjust row heights and column widths. These are fictional planning figures. Invite the audience to change the plan.</a:t>
+            </a:r>
+          </a:p>
+        </p:txBody>
+      </p:sp>
+      <p:sp>
+        <p:nvSpPr>
+          <p:cNvPr id="4" name="Slide Number Placeholder 3"/>
+          <p:cNvSpPr>
+            <a:spLocks noGrp="1"/>
+          </p:cNvSpPr>
+          <p:nvPr>
+            <p:ph type="sldNum" idx="5" sz="quarter"/>
+          </p:nvPr>
+        </p:nvSpPr>
+        <p:spPr/>
+      </p:sp>
+    </p:spTree>
+  </p:cSld>
+  <p:clrMapOvr>
+    <a:masterClrMapping/>
+  </p:clrMapOvr>
+</p:notes>
+</file>
+
+<file path=ppt/notesSlides/notesSlide5.xml><?xml version="1.0" encoding="utf-8"?>
+<p:notes xmlns:a="http://schemas.openxmlformats.org/drawingml/2006/main" xmlns:p="http://schemas.openxmlformats.org/presentationml/2006/main" xmlns:r="http://schemas.openxmlformats.org/officeDocument/2006/relationships">
+  <p:cSld>
+    <p:spTree>
+      <p:nvGrpSpPr>
+        <p:cNvPr id="1" name=""/>
+        <p:cNvGrpSpPr/>
+        <p:nvPr/>
+      </p:nvGrpSpPr>
+      <p:grpSpPr>
+        <a:xfrm>
+          <a:off x="0" y="0"/>
+          <a:ext cx="0" cy="0"/>
+          <a:chOff x="0" y="0"/>
+          <a:chExt cx="0" cy="0"/>
+        </a:xfrm>
+      </p:grpSpPr>
+      <p:sp>
+        <p:nvSpPr>
+          <p:cNvPr id="2" name="Slide Image Placeholder 1"/>
+          <p:cNvSpPr>
+            <a:spLocks noGrp="1"/>
+          </p:cNvSpPr>
+          <p:nvPr>
+            <p:ph type="sldImg" idx="2"/>
+          </p:nvPr>
+        </p:nvSpPr>
+        <p:spPr/>
+      </p:sp>
+      <p:sp>
+        <p:nvSpPr>
+          <p:cNvPr id="3" name="Notes Placeholder 2"/>
+          <p:cNvSpPr>
+            <a:spLocks noGrp="1"/>
+          </p:cNvSpPr>
+          <p:nvPr>
+            <p:ph type="body" idx="3" sz="quarter"/>
+          </p:nvPr>
+        </p:nvSpPr>
+        <p:spPr/>
+        <p:txBody>
+          <a:bodyPr/>
+          <a:lstStyle/>
+          <a:p>
+            <a:r>
+              <a:t>Try it: select the SmartArt diagram, move or resize it, then save and reopen the deck. These are fictional planning figures. Invite the audience to change the plan.</a:t>
+            </a:r>
+          </a:p>
+        </p:txBody>
+      </p:sp>
+      <p:sp>
+        <p:nvSpPr>
+          <p:cNvPr id="4" name="Slide Number Placeholder 3"/>
+          <p:cNvSpPr>
+            <a:spLocks noGrp="1"/>
+          </p:cNvSpPr>
+          <p:nvPr>
+            <p:ph type="sldNum" idx="5" sz="quarter"/>
+          </p:nvPr>
+        </p:nvSpPr>
+        <p:spPr/>
+      </p:sp>
+    </p:spTree>
+  </p:cSld>
+  <p:clrMapOvr>
+    <a:masterClrMapping/>
+  </p:clrMapOvr>
+</p:notes>
+</file>
+
+<file path=ppt/notesSlides/notesSlide6.xml><?xml version="1.0" encoding="utf-8"?>
+<p:notes xmlns:a="http://schemas.openxmlformats.org/drawingml/2006/main" xmlns:p="http://schemas.openxmlformats.org/presentationml/2006/main" xmlns:r="http://schemas.openxmlformats.org/officeDocument/2006/relationships">
+  <p:cSld>
+    <p:spTree>
+      <p:nvGrpSpPr>
+        <p:cNvPr id="1" name=""/>
+        <p:cNvGrpSpPr/>
+        <p:nvPr/>
+      </p:nvGrpSpPr>
+      <p:grpSpPr>
+        <a:xfrm>
+          <a:off x="0" y="0"/>
+          <a:ext cx="0" cy="0"/>
+          <a:chOff x="0" y="0"/>
+          <a:chExt cx="0" cy="0"/>
+        </a:xfrm>
+      </p:grpSpPr>
+      <p:sp>
+        <p:nvSpPr>
+          <p:cNvPr id="2" name="Slide Image Placeholder 1"/>
+          <p:cNvSpPr>
+            <a:spLocks noGrp="1"/>
+          </p:cNvSpPr>
+          <p:nvPr>
+            <p:ph type="sldImg" idx="2"/>
+          </p:nvPr>
+        </p:nvSpPr>
+        <p:spPr/>
+      </p:sp>
+      <p:sp>
+        <p:nvSpPr>
+          <p:cNvPr id="3" name="Notes Placeholder 2"/>
+          <p:cNvSpPr>
+            <a:spLocks noGrp="1"/>
+          </p:cNvSpPr>
+          <p:nvPr>
+            <p:ph type="body" idx="3" sz="quarter"/>
+          </p:nvPr>
+        </p:nvSpPr>
+        <p:spPr/>
+        <p:txBody>
+          <a:bodyPr/>
+          <a:lstStyle/>
+          <a:p>
+            <a:r>
+              <a:t>Try it: change the line and area chart values to explore a different season. These are fictional planning figures. Invite the audience to change the plan.</a:t>
+            </a:r>
+          </a:p>
+        </p:txBody>
+      </p:sp>
+      <p:sp>
+        <p:nvSpPr>
+          <p:cNvPr id="4" name="Slide Number Placeholder 3"/>
+          <p:cNvSpPr>
+            <a:spLocks noGrp="1"/>
+          </p:cNvSpPr>
+          <p:nvPr>
+            <p:ph type="sldNum" idx="5" sz="quarter"/>
+          </p:nvPr>
+        </p:nvSpPr>
+        <p:spPr/>
+      </p:sp>
+    </p:spTree>
+  </p:cSld>
+  <p:clrMapOvr>
+    <a:masterClrMapping/>
+  </p:clrMapOvr>
+</p:notes>
+</file>
+
+<file path=ppt/notesSlides/notesSlide7.xml><?xml version="1.0" encoding="utf-8"?>
+<p:notes xmlns:a="http://schemas.openxmlformats.org/drawingml/2006/main" xmlns:p="http://schemas.openxmlformats.org/presentationml/2006/main" xmlns:r="http://schemas.openxmlformats.org/officeDocument/2006/relationships">
+  <p:cSld>
+    <p:spTree>
+      <p:nvGrpSpPr>
+        <p:cNvPr id="1" name=""/>
+        <p:cNvGrpSpPr/>
+        <p:nvPr/>
+      </p:nvGrpSpPr>
+      <p:grpSpPr>
+        <a:xfrm>
+          <a:off x="0" y="0"/>
+          <a:ext cx="0" cy="0"/>
+          <a:chOff x="0" y="0"/>
+          <a:chExt cx="0" cy="0"/>
+        </a:xfrm>
+      </p:grpSpPr>
+      <p:sp>
+        <p:nvSpPr>
+          <p:cNvPr id="2" name="Slide Image Placeholder 1"/>
+          <p:cNvSpPr>
+            <a:spLocks noGrp="1"/>
+          </p:cNvSpPr>
+          <p:nvPr>
+            <p:ph type="sldImg" idx="2"/>
+          </p:nvPr>
+        </p:nvSpPr>
+        <p:spPr/>
+      </p:sp>
+      <p:sp>
+        <p:nvSpPr>
+          <p:cNvPr id="3" name="Notes Placeholder 2"/>
+          <p:cNvSpPr>
+            <a:spLocks noGrp="1"/>
+          </p:cNvSpPr>
+          <p:nvPr>
+            <p:ph type="body" idx="3" sz="quarter"/>
+          </p:nvPr>
+        </p:nvSpPr>
+        <p:spPr/>
+        <p:txBody>
+          <a:bodyPr/>
+          <a:lstStyle/>
+          <a:p>
+            <a:r>
+              <a:t>Try it: compare a bar chart with a pie chart. Change the chart colors and labels. These are fictional planning figures. Invite the audience to change the plan.</a:t>
+            </a:r>
+          </a:p>
+        </p:txBody>
+      </p:sp>
+      <p:sp>
+        <p:nvSpPr>
+          <p:cNvPr id="4" name="Slide Number Placeholder 3"/>
+          <p:cNvSpPr>
+            <a:spLocks noGrp="1"/>
+          </p:cNvSpPr>
+          <p:nvPr>
+            <p:ph type="sldNum" idx="5" sz="quarter"/>
+          </p:nvPr>
+        </p:nvSpPr>
+        <p:spPr/>
+      </p:sp>
+    </p:spTree>
+  </p:cSld>
+  <p:clrMapOvr>
+    <a:masterClrMapping/>
+  </p:clrMapOvr>
+</p:notes>
+</file>
+
+<file path=ppt/notesSlides/notesSlide8.xml><?xml version="1.0" encoding="utf-8"?>
+<p:notes xmlns:a="http://schemas.openxmlformats.org/drawingml/2006/main" xmlns:p="http://schemas.openxmlformats.org/presentationml/2006/main" xmlns:r="http://schemas.openxmlformats.org/officeDocument/2006/relationships">
+  <p:cSld>
+    <p:spTree>
+      <p:nvGrpSpPr>
+        <p:cNvPr id="1" name=""/>
+        <p:cNvGrpSpPr/>
+        <p:nvPr/>
+      </p:nvGrpSpPr>
+      <p:grpSpPr>
+        <a:xfrm>
+          <a:off x="0" y="0"/>
+          <a:ext cx="0" cy="0"/>
+          <a:chOff x="0" y="0"/>
+          <a:chExt cx="0" cy="0"/>
+        </a:xfrm>
+      </p:grpSpPr>
+      <p:sp>
+        <p:nvSpPr>
+          <p:cNvPr id="2" name="Slide Image Placeholder 1"/>
+          <p:cNvSpPr>
+            <a:spLocks noGrp="1"/>
+          </p:cNvSpPr>
+          <p:nvPr>
+            <p:ph type="sldImg" idx="2"/>
+          </p:nvPr>
+        </p:nvSpPr>
+        <p:spPr/>
+      </p:sp>
+      <p:sp>
+        <p:nvSpPr>
+          <p:cNvPr id="3" name="Notes Placeholder 2"/>
+          <p:cNvSpPr>
+            <a:spLocks noGrp="1"/>
+          </p:cNvSpPr>
+          <p:nvPr>
+            <p:ph type="body" idx="3" sz="quarter"/>
+          </p:nvPr>
+        </p:nvSpPr>
+        <p:spPr/>
+        <p:txBody>
+          <a:bodyPr/>
+          <a:lstStyle/>
+          <a:p>
+            <a:r>
+              <a:t>Try it: edit a scatter plot point or a doughnut segment. All charts contain real data. These are fictional planning figures. Invite the audience to change the plan.</a:t>
+            </a:r>
+          </a:p>
+        </p:txBody>
+      </p:sp>
+      <p:sp>
+        <p:nvSpPr>
+          <p:cNvPr id="4" name="Slide Number Placeholder 3"/>
+          <p:cNvSpPr>
+            <a:spLocks noGrp="1"/>
+          </p:cNvSpPr>
+          <p:nvPr>
+            <p:ph type="sldNum" idx="5" sz="quarter"/>
+          </p:nvPr>
+        </p:nvSpPr>
+        <p:spPr/>
+      </p:sp>
+    </p:spTree>
+  </p:cSld>
+  <p:clrMapOvr>
+    <a:masterClrMapping/>
+  </p:clrMapOvr>
+</p:notes>
+</file>
+
+<file path=ppt/notesSlides/notesSlide9.xml><?xml version="1.0" encoding="utf-8"?>
+<p:notes xmlns:a="http://schemas.openxmlformats.org/drawingml/2006/main" xmlns:p="http://schemas.openxmlformats.org/presentationml/2006/main" xmlns:r="http://schemas.openxmlformats.org/officeDocument/2006/relationships">
+  <p:cSld>
+    <p:spTree>
+      <p:nvGrpSpPr>
+        <p:cNvPr id="1" name=""/>
+        <p:cNvGrpSpPr/>
+        <p:nvPr/>
+      </p:nvGrpSpPr>
+      <p:grpSpPr>
+        <a:xfrm>
+          <a:off x="0" y="0"/>
+          <a:ext cx="0" cy="0"/>
+          <a:chOff x="0" y="0"/>
+          <a:chExt cx="0" cy="0"/>
+        </a:xfrm>
+      </p:grpSpPr>
+      <p:sp>
+        <p:nvSpPr>
+          <p:cNvPr id="2" name="Slide Image Placeholder 1"/>
+          <p:cNvSpPr>
+            <a:spLocks noGrp="1"/>
+          </p:cNvSpPr>
+          <p:nvPr>
+            <p:ph type="sldImg" idx="2"/>
+          </p:nvPr>
+        </p:nvSpPr>
+        <p:spPr/>
+      </p:sp>
+      <p:sp>
+        <p:nvSpPr>
+          <p:cNvPr id="3" name="Notes Placeholder 2"/>
+          <p:cNvSpPr>
+            <a:spLocks noGrp="1"/>
+          </p:cNvSpPr>
+          <p:nvPr>
+            <p:ph type="body" idx="3" sz="quarter"/>
+          </p:nvPr>
+        </p:nvSpPr>
+        <p:spPr/>
+        <p:txBody>
+          <a:bodyPr/>
+          <a:lstStyle/>
+          <a:p>
+            <a:r>
+              <a:t>Try it: change the WordArt, rotate the star, or add a new slide using a different layout. These are fictional planning figures. Invite the audience to change the plan.</a:t>
             </a:r>
           </a:p>
         </p:txBody>
@@ -3718,8 +5261,8 @@
         </p:nvSpPr>
         <p:spPr>
           <a:xfrm>
-            <a:off x="594360" y="438912"/>
-            <a:ext cx="10058400" cy="365760"/>
+            <a:off x="594360" y="320040"/>
+            <a:ext cx="10972800" cy="457200"/>
           </a:xfrm>
           <a:prstGeom prst="rect">
             <a:avLst/>
@@ -3733,7 +5276,7 @@
           <a:lstStyle/>
           <a:p>
             <a:pPr>
-              <a:defRPr sz="1400" b="1">
+              <a:defRPr sz="1200" b="1">
                 <a:solidFill>
                   <a:srgbClr val="AC4328"/>
                 </a:solidFill>
@@ -3741,7 +5284,7 @@
               </a:defRPr>
             </a:pPr>
             <a:r>
-              <a:t>FIELD NOTES / COMMUNITY GARDEN</a:t>
+              <a:t>FIELD NOTES / COMMUNITY GARDEN   /   01</a:t>
             </a:r>
           </a:p>
         </p:txBody>
@@ -3754,8 +5297,8 @@
         </p:nvSpPr>
         <p:spPr>
           <a:xfrm>
-            <a:off x="594360" y="1143000"/>
-            <a:ext cx="5486400" cy="2103120"/>
+            <a:off x="594360" y="960120"/>
+            <a:ext cx="5486400" cy="2194560"/>
           </a:xfrm>
           <a:prstGeom prst="rect">
             <a:avLst/>
@@ -3803,8 +5346,44 @@
         </p:nvSpPr>
         <p:spPr>
           <a:xfrm>
-            <a:off x="594360" y="3657600"/>
-            <a:ext cx="4663440" cy="1005840"/>
+            <a:off x="594360" y="6263640"/>
+            <a:ext cx="10972800" cy="365760"/>
+          </a:xfrm>
+          <a:prstGeom prst="rect">
+            <a:avLst/>
+          </a:prstGeom>
+          <a:noFill/>
+        </p:spPr>
+        <p:txBody>
+          <a:bodyPr wrap="square">
+            <a:spAutoFit/>
+          </a:bodyPr>
+          <a:lstStyle/>
+          <a:p>
+            <a:pPr>
+              <a:defRPr sz="1200" b="0">
+                <a:solidFill>
+                  <a:srgbClr val="AC4328"/>
+                </a:solidFill>
+                <a:latin typeface="Calibri"/>
+              </a:defRPr>
+            </a:pPr>
+            <a:r>
+              <a:t>Try it: edit the chart data. Start Slide Show to present; open Presenter View for notes.</a:t>
+            </a:r>
+          </a:p>
+        </p:txBody>
+      </p:sp>
+      <p:sp>
+        <p:nvSpPr>
+          <p:cNvPr id="6" name="TextBox 5"/>
+          <p:cNvSpPr txBox="1"/>
+          <p:nvPr/>
+        </p:nvSpPr>
+        <p:spPr>
+          <a:xfrm>
+            <a:off x="594360" y="3474720"/>
+            <a:ext cx="5303520" cy="1097280"/>
           </a:xfrm>
           <a:prstGeom prst="rect">
             <a:avLst/>
@@ -3846,14 +5425,14 @@
       </p:sp>
       <p:sp>
         <p:nvSpPr>
-          <p:cNvPr id="6" name="TextBox 5"/>
+          <p:cNvPr id="7" name="TextBox 6"/>
           <p:cNvSpPr txBox="1"/>
           <p:nvPr/>
         </p:nvSpPr>
         <p:spPr>
           <a:xfrm>
-            <a:off x="594360" y="5212080"/>
-            <a:ext cx="1645920" cy="594360"/>
+            <a:off x="594360" y="4937760"/>
+            <a:ext cx="1645920" cy="548640"/>
           </a:xfrm>
           <a:prstGeom prst="rect">
             <a:avLst/>
@@ -3882,14 +5461,14 @@
       </p:sp>
       <p:sp>
         <p:nvSpPr>
-          <p:cNvPr id="7" name="TextBox 6"/>
+          <p:cNvPr id="8" name="TextBox 7"/>
           <p:cNvSpPr txBox="1"/>
           <p:nvPr/>
         </p:nvSpPr>
         <p:spPr>
           <a:xfrm>
-            <a:off x="594360" y="5806440"/>
-            <a:ext cx="1737360" cy="365760"/>
+            <a:off x="594360" y="5486400"/>
+            <a:ext cx="1828800" cy="365760"/>
           </a:xfrm>
           <a:prstGeom prst="rect">
             <a:avLst/>
@@ -3918,14 +5497,14 @@
       </p:sp>
       <p:sp>
         <p:nvSpPr>
-          <p:cNvPr id="8" name="TextBox 7"/>
+          <p:cNvPr id="9" name="TextBox 8"/>
           <p:cNvSpPr txBox="1"/>
           <p:nvPr/>
         </p:nvSpPr>
         <p:spPr>
           <a:xfrm>
-            <a:off x="2423160" y="5212080"/>
-            <a:ext cx="1645920" cy="594360"/>
+            <a:off x="2423160" y="4937760"/>
+            <a:ext cx="1645920" cy="548640"/>
           </a:xfrm>
           <a:prstGeom prst="rect">
             <a:avLst/>
@@ -3954,14 +5533,14 @@
       </p:sp>
       <p:sp>
         <p:nvSpPr>
-          <p:cNvPr id="9" name="TextBox 8"/>
+          <p:cNvPr id="10" name="TextBox 9"/>
           <p:cNvSpPr txBox="1"/>
           <p:nvPr/>
         </p:nvSpPr>
         <p:spPr>
           <a:xfrm>
-            <a:off x="2423160" y="5806440"/>
-            <a:ext cx="1737360" cy="365760"/>
+            <a:off x="2423160" y="5486400"/>
+            <a:ext cx="1828800" cy="365760"/>
           </a:xfrm>
           <a:prstGeom prst="rect">
             <a:avLst/>
@@ -3990,14 +5569,14 @@
       </p:sp>
       <p:sp>
         <p:nvSpPr>
-          <p:cNvPr id="10" name="TextBox 9"/>
+          <p:cNvPr id="11" name="TextBox 10"/>
           <p:cNvSpPr txBox="1"/>
           <p:nvPr/>
         </p:nvSpPr>
         <p:spPr>
           <a:xfrm>
-            <a:off x="4251960" y="5212080"/>
-            <a:ext cx="1645920" cy="594360"/>
+            <a:off x="4251960" y="4937760"/>
+            <a:ext cx="1645920" cy="548640"/>
           </a:xfrm>
           <a:prstGeom prst="rect">
             <a:avLst/>
@@ -4026,14 +5605,14 @@
       </p:sp>
       <p:sp>
         <p:nvSpPr>
-          <p:cNvPr id="11" name="TextBox 10"/>
+          <p:cNvPr id="12" name="TextBox 11"/>
           <p:cNvSpPr txBox="1"/>
           <p:nvPr/>
         </p:nvSpPr>
         <p:spPr>
           <a:xfrm>
-            <a:off x="4251960" y="5806440"/>
-            <a:ext cx="1737360" cy="365760"/>
+            <a:off x="4251960" y="5486400"/>
+            <a:ext cx="1828800" cy="365760"/>
           </a:xfrm>
           <a:prstGeom prst="rect">
             <a:avLst/>
@@ -4062,7 +5641,7 @@
       </p:sp>
       <p:graphicFrame>
         <p:nvGraphicFramePr>
-          <p:cNvPr id="12" name="Chart 11"/>
+          <p:cNvPr id="13" name="Chart 12"/>
           <p:cNvGraphicFramePr>
             <a:graphicFrameLocks noGrp="1"/>
           </p:cNvGraphicFramePr>
@@ -4074,7 +5653,7 @@
         </p:xfrm>
         <a:graphic>
           <a:graphicData uri="http://schemas.openxmlformats.org/drawingml/2006/chart">
-            <c:chart xmlns:c="http://schemas.openxmlformats.org/drawingml/2006/chart" r:id="rId2"/>
+            <c:chart xmlns:c="http://schemas.openxmlformats.org/drawingml/2006/chart" r:id="rId3"/>
           </a:graphicData>
         </a:graphic>
       </p:graphicFrame>
@@ -4155,8 +5734,8 @@
         </p:nvSpPr>
         <p:spPr>
           <a:xfrm>
-            <a:off x="731520" y="594360"/>
-            <a:ext cx="9144000" cy="457200"/>
+            <a:off x="594360" y="320040"/>
+            <a:ext cx="10972800" cy="457200"/>
           </a:xfrm>
           <a:prstGeom prst="rect">
             <a:avLst/>
@@ -4170,7 +5749,7 @@
           <a:lstStyle/>
           <a:p>
             <a:pPr>
-              <a:defRPr sz="1600" b="1">
+              <a:defRPr sz="1200" b="1">
                 <a:solidFill>
                   <a:srgbClr val="AC4328"/>
                 </a:solidFill>
@@ -4178,7 +5757,7 @@
               </a:defRPr>
             </a:pPr>
             <a:r>
-              <a:t>FIELD NOTES / 01</a:t>
+              <a:t>FIELD NOTES / COMMUNITY GARDEN   /   02</a:t>
             </a:r>
           </a:p>
         </p:txBody>
@@ -4191,8 +5770,8 @@
         </p:nvSpPr>
         <p:spPr>
           <a:xfrm>
-            <a:off x="731520" y="2011680"/>
-            <a:ext cx="10058400" cy="1828800"/>
+            <a:off x="594360" y="960120"/>
+            <a:ext cx="10972800" cy="914400"/>
           </a:xfrm>
           <a:prstGeom prst="rect">
             <a:avLst/>
@@ -4206,7 +5785,7 @@
           <a:lstStyle/>
           <a:p>
             <a:pPr>
-              <a:defRPr sz="4400" b="1">
+              <a:defRPr sz="3200" b="1">
                 <a:solidFill>
                   <a:srgbClr val="192B40"/>
                 </a:solidFill>
@@ -4227,8 +5806,8 @@
         </p:nvSpPr>
         <p:spPr>
           <a:xfrm>
-            <a:off x="731520" y="4114800"/>
-            <a:ext cx="10058400" cy="1097280"/>
+            <a:off x="594360" y="6263640"/>
+            <a:ext cx="10972800" cy="365760"/>
           </a:xfrm>
           <a:prstGeom prst="rect">
             <a:avLst/>
@@ -4242,7 +5821,67 @@
           <a:lstStyle/>
           <a:p>
             <a:pPr>
-              <a:defRPr sz="2500" b="0">
+              <a:defRPr sz="1200" b="0">
+                <a:solidFill>
+                  <a:srgbClr val="AC4328"/>
+                </a:solidFill>
+                <a:latin typeface="Calibri"/>
+              </a:defRPr>
+            </a:pPr>
+            <a:r>
+              <a:t>Try it: move or resize the picture, edit the caption, and add a link to the text.</a:t>
+            </a:r>
+          </a:p>
+        </p:txBody>
+      </p:sp>
+      <p:pic>
+        <p:nvPicPr>
+          <p:cNvPr id="6" name="Picture 5" descr="image.png"/>
+          <p:cNvPicPr>
+            <a:picLocks noChangeAspect="1"/>
+          </p:cNvPicPr>
+          <p:nvPr/>
+        </p:nvPicPr>
+        <p:blipFill>
+          <a:blip r:embed="rId3"/>
+          <a:stretch>
+            <a:fillRect/>
+          </a:stretch>
+        </p:blipFill>
+        <p:spPr>
+          <a:xfrm>
+            <a:off x="640080" y="2194560"/>
+            <a:ext cx="7406640" cy="2592324"/>
+          </a:xfrm>
+          <a:prstGeom prst="rect">
+            <a:avLst/>
+          </a:prstGeom>
+        </p:spPr>
+      </p:pic>
+      <p:sp>
+        <p:nvSpPr>
+          <p:cNvPr id="7" name="TextBox 6"/>
+          <p:cNvSpPr txBox="1"/>
+          <p:nvPr/>
+        </p:nvSpPr>
+        <p:spPr>
+          <a:xfrm>
+            <a:off x="8458200" y="2286000"/>
+            <a:ext cx="2834640" cy="3200400"/>
+          </a:xfrm>
+          <a:prstGeom prst="rect">
+            <a:avLst/>
+          </a:prstGeom>
+          <a:noFill/>
+        </p:spPr>
+        <p:txBody>
+          <a:bodyPr wrap="square">
+            <a:spAutoFit/>
+          </a:bodyPr>
+          <a:lstStyle/>
+          <a:p>
+            <a:pPr>
+              <a:defRPr sz="2400" b="0">
                 <a:solidFill>
                   <a:srgbClr val="192B40"/>
                 </a:solidFill>
@@ -4250,7 +5889,82 @@
               </a:defRPr>
             </a:pPr>
             <a:r>
-              <a:t>Open mornings. Shared tools. Space to learn.</a:t>
+              <a:t>Six raised beds.</a:t>
+            </a:r>
+          </a:p>
+          <a:p>
+            <a:pPr>
+              <a:defRPr sz="2400" b="0">
+                <a:solidFill>
+                  <a:srgbClr val="192B40"/>
+                </a:solidFill>
+                <a:latin typeface="Calibri"/>
+              </a:defRPr>
+            </a:pPr>
+            <a:r>
+              <a:t>Shared tools.</a:t>
+            </a:r>
+          </a:p>
+          <a:p>
+            <a:pPr>
+              <a:defRPr sz="2400" b="0">
+                <a:solidFill>
+                  <a:srgbClr val="192B40"/>
+                </a:solidFill>
+                <a:latin typeface="Calibri"/>
+              </a:defRPr>
+            </a:pPr>
+            <a:r>
+              <a:t>Open mornings.</a:t>
+            </a:r>
+          </a:p>
+          <a:p>
+            <a:pPr>
+              <a:defRPr sz="2400" b="0">
+                <a:solidFill>
+                  <a:srgbClr val="192B40"/>
+                </a:solidFill>
+                <a:latin typeface="Calibri"/>
+              </a:defRPr>
+            </a:pPr>
+            <a:r>
+              <a:t>Space to learn.</a:t>
+            </a:r>
+          </a:p>
+        </p:txBody>
+      </p:sp>
+      <p:sp>
+        <p:nvSpPr>
+          <p:cNvPr id="8" name="TextBox 7"/>
+          <p:cNvSpPr txBox="1"/>
+          <p:nvPr/>
+        </p:nvSpPr>
+        <p:spPr>
+          <a:xfrm>
+            <a:off x="640080" y="5212080"/>
+            <a:ext cx="10058400" cy="457200"/>
+          </a:xfrm>
+          <a:prstGeom prst="rect">
+            <a:avLst/>
+          </a:prstGeom>
+          <a:noFill/>
+        </p:spPr>
+        <p:txBody>
+          <a:bodyPr wrap="square">
+            <a:spAutoFit/>
+          </a:bodyPr>
+          <a:lstStyle/>
+          <a:p>
+            <a:pPr>
+              <a:defRPr sz="1800" b="0">
+                <a:solidFill>
+                  <a:srgbClr val="192B40"/>
+                </a:solidFill>
+                <a:latin typeface="Calibri"/>
+              </a:defRPr>
+            </a:pPr>
+            <a:r>
+              <a:t>A simple site plan, embedded as a picture.</a:t>
             </a:r>
           </a:p>
         </p:txBody>
@@ -4332,8 +6046,8 @@
         </p:nvSpPr>
         <p:spPr>
           <a:xfrm>
-            <a:off x="731520" y="594360"/>
-            <a:ext cx="9144000" cy="457200"/>
+            <a:off x="594360" y="320040"/>
+            <a:ext cx="10972800" cy="457200"/>
           </a:xfrm>
           <a:prstGeom prst="rect">
             <a:avLst/>
@@ -4347,7 +6061,7 @@
           <a:lstStyle/>
           <a:p>
             <a:pPr>
-              <a:defRPr sz="1600" b="1">
+              <a:defRPr sz="1200" b="1">
                 <a:solidFill>
                   <a:srgbClr val="AC4328"/>
                 </a:solidFill>
@@ -4355,7 +6069,7 @@
               </a:defRPr>
             </a:pPr>
             <a:r>
-              <a:t>FIELD NOTES / 02</a:t>
+              <a:t>FIELD NOTES / COMMUNITY GARDEN   /   03</a:t>
             </a:r>
           </a:p>
         </p:txBody>
@@ -4368,8 +6082,8 @@
         </p:nvSpPr>
         <p:spPr>
           <a:xfrm>
-            <a:off x="731520" y="2011680"/>
-            <a:ext cx="10058400" cy="1828800"/>
+            <a:off x="594360" y="960120"/>
+            <a:ext cx="10972800" cy="914400"/>
           </a:xfrm>
           <a:prstGeom prst="rect">
             <a:avLst/>
@@ -4383,7 +6097,7 @@
           <a:lstStyle/>
           <a:p>
             <a:pPr>
-              <a:defRPr sz="4400" b="1">
+              <a:defRPr sz="3200" b="1">
                 <a:solidFill>
                   <a:srgbClr val="192B40"/>
                 </a:solidFill>
@@ -4404,8 +6118,8 @@
         </p:nvSpPr>
         <p:spPr>
           <a:xfrm>
-            <a:off x="731520" y="4114800"/>
-            <a:ext cx="10058400" cy="1097280"/>
+            <a:off x="594360" y="6263640"/>
+            <a:ext cx="10972800" cy="365760"/>
           </a:xfrm>
           <a:prstGeom prst="rect">
             <a:avLst/>
@@ -4419,7 +6133,251 @@
           <a:lstStyle/>
           <a:p>
             <a:pPr>
-              <a:defRPr sz="2500" b="0">
+              <a:defRPr sz="1200" b="0">
+                <a:solidFill>
+                  <a:srgbClr val="AC4328"/>
+                </a:solidFill>
+                <a:latin typeface="Calibri"/>
+              </a:defRPr>
+            </a:pPr>
+            <a:r>
+              <a:t>Try it: edit and align the shapes. In Slide Show, click to reveal the final step with a wipe.</a:t>
+            </a:r>
+          </a:p>
+        </p:txBody>
+      </p:sp>
+      <p:sp>
+        <p:nvSpPr>
+          <p:cNvPr id="6" name="Chevron 5"/>
+          <p:cNvSpPr/>
+          <p:nvPr/>
+        </p:nvSpPr>
+        <p:spPr>
+          <a:xfrm>
+            <a:off x="640080" y="2468880"/>
+            <a:ext cx="2468880" cy="1554480"/>
+          </a:xfrm>
+          <a:prstGeom prst="chevron">
+            <a:avLst/>
+          </a:prstGeom>
+          <a:solidFill>
+            <a:srgbClr val="2449DF"/>
+          </a:solidFill>
+          <a:ln>
+            <a:noFill/>
+          </a:ln>
+        </p:spPr>
+        <p:style>
+          <a:lnRef idx="1">
+            <a:schemeClr val="accent1"/>
+          </a:lnRef>
+          <a:fillRef idx="3">
+            <a:schemeClr val="accent1"/>
+          </a:fillRef>
+          <a:effectRef idx="2">
+            <a:schemeClr val="accent1"/>
+          </a:effectRef>
+          <a:fontRef idx="minor">
+            <a:schemeClr val="lt1"/>
+          </a:fontRef>
+        </p:style>
+        <p:txBody>
+          <a:bodyPr rtlCol="0" anchor="ctr"/>
+          <a:lstStyle/>
+          <a:p>
+            <a:pPr>
+              <a:defRPr sz="2200">
+                <a:solidFill>
+                  <a:srgbClr val="FFFFFF"/>
+                </a:solidFill>
+              </a:defRPr>
+            </a:pPr>
+            <a:r>
+              <a:t>Listen</a:t>
+            </a:r>
+          </a:p>
+        </p:txBody>
+      </p:sp>
+      <p:sp>
+        <p:nvSpPr>
+          <p:cNvPr id="7" name="Chevron 6"/>
+          <p:cNvSpPr/>
+          <p:nvPr/>
+        </p:nvSpPr>
+        <p:spPr>
+          <a:xfrm>
+            <a:off x="3520439" y="2468880"/>
+            <a:ext cx="2468880" cy="1554480"/>
+          </a:xfrm>
+          <a:prstGeom prst="chevron">
+            <a:avLst/>
+          </a:prstGeom>
+          <a:solidFill>
+            <a:srgbClr val="17644F"/>
+          </a:solidFill>
+          <a:ln>
+            <a:noFill/>
+          </a:ln>
+        </p:spPr>
+        <p:style>
+          <a:lnRef idx="1">
+            <a:schemeClr val="accent1"/>
+          </a:lnRef>
+          <a:fillRef idx="3">
+            <a:schemeClr val="accent1"/>
+          </a:fillRef>
+          <a:effectRef idx="2">
+            <a:schemeClr val="accent1"/>
+          </a:effectRef>
+          <a:fontRef idx="minor">
+            <a:schemeClr val="lt1"/>
+          </a:fontRef>
+        </p:style>
+        <p:txBody>
+          <a:bodyPr rtlCol="0" anchor="ctr"/>
+          <a:lstStyle/>
+          <a:p>
+            <a:pPr>
+              <a:defRPr sz="2200">
+                <a:solidFill>
+                  <a:srgbClr val="FFFFFF"/>
+                </a:solidFill>
+              </a:defRPr>
+            </a:pPr>
+            <a:r>
+              <a:t>Build</a:t>
+            </a:r>
+          </a:p>
+        </p:txBody>
+      </p:sp>
+      <p:sp>
+        <p:nvSpPr>
+          <p:cNvPr id="8" name="Chevron 7"/>
+          <p:cNvSpPr/>
+          <p:nvPr/>
+        </p:nvSpPr>
+        <p:spPr>
+          <a:xfrm>
+            <a:off x="6400800" y="2468880"/>
+            <a:ext cx="2468880" cy="1554480"/>
+          </a:xfrm>
+          <a:prstGeom prst="chevron">
+            <a:avLst/>
+          </a:prstGeom>
+          <a:solidFill>
+            <a:srgbClr val="AC4328"/>
+          </a:solidFill>
+          <a:ln>
+            <a:noFill/>
+          </a:ln>
+        </p:spPr>
+        <p:style>
+          <a:lnRef idx="1">
+            <a:schemeClr val="accent1"/>
+          </a:lnRef>
+          <a:fillRef idx="3">
+            <a:schemeClr val="accent1"/>
+          </a:fillRef>
+          <a:effectRef idx="2">
+            <a:schemeClr val="accent1"/>
+          </a:effectRef>
+          <a:fontRef idx="minor">
+            <a:schemeClr val="lt1"/>
+          </a:fontRef>
+        </p:style>
+        <p:txBody>
+          <a:bodyPr rtlCol="0" anchor="ctr"/>
+          <a:lstStyle/>
+          <a:p>
+            <a:pPr>
+              <a:defRPr sz="2200">
+                <a:solidFill>
+                  <a:srgbClr val="FFFFFF"/>
+                </a:solidFill>
+              </a:defRPr>
+            </a:pPr>
+            <a:r>
+              <a:t>Plant</a:t>
+            </a:r>
+          </a:p>
+        </p:txBody>
+      </p:sp>
+      <p:sp>
+        <p:nvSpPr>
+          <p:cNvPr id="9" name="Chevron 8"/>
+          <p:cNvSpPr/>
+          <p:nvPr/>
+        </p:nvSpPr>
+        <p:spPr>
+          <a:xfrm>
+            <a:off x="9281159" y="2468880"/>
+            <a:ext cx="2468880" cy="1554480"/>
+          </a:xfrm>
+          <a:prstGeom prst="chevron">
+            <a:avLst/>
+          </a:prstGeom>
+          <a:solidFill>
+            <a:srgbClr val="7150A0"/>
+          </a:solidFill>
+          <a:ln>
+            <a:noFill/>
+          </a:ln>
+        </p:spPr>
+        <p:style>
+          <a:lnRef idx="1">
+            <a:schemeClr val="accent1"/>
+          </a:lnRef>
+          <a:fillRef idx="3">
+            <a:schemeClr val="accent1"/>
+          </a:fillRef>
+          <a:effectRef idx="2">
+            <a:schemeClr val="accent1"/>
+          </a:effectRef>
+          <a:fontRef idx="minor">
+            <a:schemeClr val="lt1"/>
+          </a:fontRef>
+        </p:style>
+        <p:txBody>
+          <a:bodyPr rtlCol="0" anchor="ctr"/>
+          <a:lstStyle/>
+          <a:p>
+            <a:pPr>
+              <a:defRPr sz="2200">
+                <a:solidFill>
+                  <a:srgbClr val="FFFFFF"/>
+                </a:solidFill>
+              </a:defRPr>
+            </a:pPr>
+            <a:r>
+              <a:t>Grow</a:t>
+            </a:r>
+          </a:p>
+        </p:txBody>
+      </p:sp>
+      <p:sp>
+        <p:nvSpPr>
+          <p:cNvPr id="10" name="TextBox 9"/>
+          <p:cNvSpPr txBox="1"/>
+          <p:nvPr/>
+        </p:nvSpPr>
+        <p:spPr>
+          <a:xfrm>
+            <a:off x="731520" y="4663440"/>
+            <a:ext cx="10698480" cy="731520"/>
+          </a:xfrm>
+          <a:prstGeom prst="rect">
+            <a:avLst/>
+          </a:prstGeom>
+          <a:noFill/>
+        </p:spPr>
+        <p:txBody>
+          <a:bodyPr wrap="square">
+            <a:spAutoFit/>
+          </a:bodyPr>
+          <a:lstStyle/>
+          <a:p>
+            <a:pPr>
+              <a:defRPr sz="2400" b="0">
                 <a:solidFill>
                   <a:srgbClr val="192B40"/>
                 </a:solidFill>
@@ -4427,7 +6385,7 @@
               </a:defRPr>
             </a:pPr>
             <a:r>
-              <a:t>Listen → Build → Plant → Grow</a:t>
+              <a:t>One shared plan. A little progress every week.</a:t>
             </a:r>
           </a:p>
         </p:txBody>
@@ -4437,6 +6395,91 @@
   <p:clrMapOvr>
     <a:masterClrMapping/>
   </p:clrMapOvr>
+  <p:transition spd="med">
+    <p:fade/>
+  </p:transition>
+  <p:timing>
+    <p:tnLst>
+      <p:par>
+        <p:cTn id="1" dur="indefinite" restart="never" nodeType="tmRoot">
+          <p:childTnLst>
+            <p:seq concurrent="1" nextAc="seek">
+              <p:cTn id="2" dur="indefinite" nodeType="mainSeq">
+                <p:childTnLst>
+                  <p:par>
+                    <p:cTn id="3" fill="hold">
+                      <p:stCondLst>
+                        <p:cond delay="indefinite"/>
+                      </p:stCondLst>
+                      <p:childTnLst>
+                        <p:par>
+                          <p:cTn id="4" fill="hold">
+                            <p:stCondLst>
+                              <p:cond delay="0"/>
+                            </p:stCondLst>
+                            <p:childTnLst>
+                              <p:par>
+                                <p:cTn id="5" presetID="22" presetClass="entr" presetSubtype="8" fill="hold" nodeType="clickEffect">
+                                  <p:stCondLst>
+                                    <p:cond delay="0"/>
+                                  </p:stCondLst>
+                                  <p:childTnLst>
+                                    <p:set>
+                                      <p:cBhvr>
+                                        <p:cTn id="6" dur="1" fill="hold"/>
+                                        <p:tgtEl>
+                                          <p:spTgt spid="9"/>
+                                        </p:tgtEl>
+                                        <p:attrNameLst>
+                                          <p:attrName>style.visibility</p:attrName>
+                                        </p:attrNameLst>
+                                      </p:cBhvr>
+                                      <p:to>
+                                        <p:strVal val="visible"/>
+                                      </p:to>
+                                    </p:set>
+                                    <p:animEffect transition="in" filter="wipe(right)">
+                                      <p:cBhvr>
+                                        <p:cTn id="7" dur="700"/>
+                                        <p:tgtEl>
+                                          <p:spTgt spid="9"/>
+                                        </p:tgtEl>
+                                      </p:cBhvr>
+                                    </p:animEffect>
+                                  </p:childTnLst>
+                                </p:cTn>
+                              </p:par>
+                            </p:childTnLst>
+                          </p:cTn>
+                        </p:par>
+                      </p:childTnLst>
+                    </p:cTn>
+                  </p:par>
+                </p:childTnLst>
+              </p:cTn>
+              <p:prevCondLst>
+                <p:cond evt="onPrev" delay="0">
+                  <p:tgtEl>
+                    <p:sldTgt/>
+                  </p:tgtEl>
+                </p:cond>
+              </p:prevCondLst>
+              <p:nextCondLst>
+                <p:cond evt="onNext" delay="0">
+                  <p:tgtEl>
+                    <p:sldTgt/>
+                  </p:tgtEl>
+                </p:cond>
+              </p:nextCondLst>
+            </p:seq>
+          </p:childTnLst>
+        </p:cTn>
+      </p:par>
+    </p:tnLst>
+    <p:bldLst>
+      <p:bldP spid="9" grpId="0" animBg="1"/>
+    </p:bldLst>
+  </p:timing>
 </p:sld>
 </file>
 
@@ -4509,8 +6552,8 @@
         </p:nvSpPr>
         <p:spPr>
           <a:xfrm>
-            <a:off x="731520" y="594360"/>
-            <a:ext cx="9144000" cy="457200"/>
+            <a:off x="594360" y="320040"/>
+            <a:ext cx="10972800" cy="457200"/>
           </a:xfrm>
           <a:prstGeom prst="rect">
             <a:avLst/>
@@ -4524,7 +6567,7 @@
           <a:lstStyle/>
           <a:p>
             <a:pPr>
-              <a:defRPr sz="1600" b="1">
+              <a:defRPr sz="1200" b="1">
                 <a:solidFill>
                   <a:srgbClr val="AC4328"/>
                 </a:solidFill>
@@ -4532,7 +6575,7 @@
               </a:defRPr>
             </a:pPr>
             <a:r>
-              <a:t>FIELD NOTES / 03</a:t>
+              <a:t>FIELD NOTES / COMMUNITY GARDEN   /   04</a:t>
             </a:r>
           </a:p>
         </p:txBody>
@@ -4545,8 +6588,8 @@
         </p:nvSpPr>
         <p:spPr>
           <a:xfrm>
-            <a:off x="731520" y="2011680"/>
-            <a:ext cx="10058400" cy="1828800"/>
+            <a:off x="594360" y="960120"/>
+            <a:ext cx="10972800" cy="914400"/>
           </a:xfrm>
           <a:prstGeom prst="rect">
             <a:avLst/>
@@ -4560,7 +6603,7 @@
           <a:lstStyle/>
           <a:p>
             <a:pPr>
-              <a:defRPr sz="4400" b="1">
+              <a:defRPr sz="3200" b="1">
                 <a:solidFill>
                   <a:srgbClr val="192B40"/>
                 </a:solidFill>
@@ -4568,7 +6611,7 @@
               </a:defRPr>
             </a:pPr>
             <a:r>
-              <a:t>Let’s grow something good.</a:t>
+              <a:t>A plan people can follow.</a:t>
             </a:r>
           </a:p>
         </p:txBody>
@@ -4581,8 +6624,8 @@
         </p:nvSpPr>
         <p:spPr>
           <a:xfrm>
-            <a:off x="731520" y="4114800"/>
-            <a:ext cx="10058400" cy="1097280"/>
+            <a:off x="594360" y="6263640"/>
+            <a:ext cx="10972800" cy="365760"/>
           </a:xfrm>
           <a:prstGeom prst="rect">
             <a:avLst/>
@@ -4596,7 +6639,646 @@
           <a:lstStyle/>
           <a:p>
             <a:pPr>
-              <a:defRPr sz="2500" b="0">
+              <a:defRPr sz="1200" b="0">
+                <a:solidFill>
+                  <a:srgbClr val="AC4328"/>
+                </a:solidFill>
+                <a:latin typeface="Calibri"/>
+              </a:defRPr>
+            </a:pPr>
+            <a:r>
+              <a:t>Try it: edit table cells, change fills, and adjust row heights and column widths.</a:t>
+            </a:r>
+          </a:p>
+        </p:txBody>
+      </p:sp>
+      <p:graphicFrame>
+        <p:nvGraphicFramePr>
+          <p:cNvPr id="6" name="Table 5"/>
+          <p:cNvGraphicFramePr>
+            <a:graphicFrameLocks noGrp="1"/>
+          </p:cNvGraphicFramePr>
+          <p:nvPr/>
+        </p:nvGraphicFramePr>
+        <p:xfrm>
+          <a:off x="640080" y="2148840"/>
+          <a:ext cx="10881360" cy="3474720"/>
+        </p:xfrm>
+        <a:graphic>
+          <a:graphicData uri="http://schemas.openxmlformats.org/drawingml/2006/table">
+            <a:tbl>
+              <a:tblPr firstRow="1" bandRow="1">
+                <a:tableStyleId>{5C22544A-7EE6-4342-B048-85BDC9FD1C3A}</a:tableStyleId>
+              </a:tblPr>
+              <a:tblGrid>
+                <a:gridCol w="1005840"/>
+                <a:gridCol w="3657600"/>
+                <a:gridCol w="2926080"/>
+                <a:gridCol w="3291840"/>
+              </a:tblGrid>
+              <a:tr h="694944">
+                <a:tc>
+                  <a:txBody>
+                    <a:bodyPr/>
+                    <a:lstStyle/>
+                    <a:p>
+                      <a:pPr>
+                        <a:defRPr sz="1900">
+                          <a:solidFill>
+                            <a:srgbClr val="FFFFFF"/>
+                          </a:solidFill>
+                        </a:defRPr>
+                      </a:pPr>
+                      <a:r>
+                        <a:t>Week</a:t>
+                      </a:r>
+                    </a:p>
+                  </a:txBody>
+                  <a:tcPr>
+                    <a:solidFill>
+                      <a:srgbClr val="AC4328"/>
+                    </a:solidFill>
+                  </a:tcPr>
+                </a:tc>
+                <a:tc>
+                  <a:txBody>
+                    <a:bodyPr/>
+                    <a:lstStyle/>
+                    <a:p>
+                      <a:pPr>
+                        <a:defRPr sz="1900">
+                          <a:solidFill>
+                            <a:srgbClr val="FFFFFF"/>
+                          </a:solidFill>
+                        </a:defRPr>
+                      </a:pPr>
+                      <a:r>
+                        <a:t>Work</a:t>
+                      </a:r>
+                    </a:p>
+                  </a:txBody>
+                  <a:tcPr>
+                    <a:solidFill>
+                      <a:srgbClr val="AC4328"/>
+                    </a:solidFill>
+                  </a:tcPr>
+                </a:tc>
+                <a:tc>
+                  <a:txBody>
+                    <a:bodyPr/>
+                    <a:lstStyle/>
+                    <a:p>
+                      <a:pPr>
+                        <a:defRPr sz="1900">
+                          <a:solidFill>
+                            <a:srgbClr val="FFFFFF"/>
+                          </a:solidFill>
+                        </a:defRPr>
+                      </a:pPr>
+                      <a:r>
+                        <a:t>People</a:t>
+                      </a:r>
+                    </a:p>
+                  </a:txBody>
+                  <a:tcPr>
+                    <a:solidFill>
+                      <a:srgbClr val="AC4328"/>
+                    </a:solidFill>
+                  </a:tcPr>
+                </a:tc>
+                <a:tc>
+                  <a:txBody>
+                    <a:bodyPr/>
+                    <a:lstStyle/>
+                    <a:p>
+                      <a:pPr>
+                        <a:defRPr sz="1900">
+                          <a:solidFill>
+                            <a:srgbClr val="FFFFFF"/>
+                          </a:solidFill>
+                        </a:defRPr>
+                      </a:pPr>
+                      <a:r>
+                        <a:t>Result</a:t>
+                      </a:r>
+                    </a:p>
+                  </a:txBody>
+                  <a:tcPr>
+                    <a:solidFill>
+                      <a:srgbClr val="AC4328"/>
+                    </a:solidFill>
+                  </a:tcPr>
+                </a:tc>
+              </a:tr>
+              <a:tr h="694944">
+                <a:tc>
+                  <a:txBody>
+                    <a:bodyPr/>
+                    <a:lstStyle/>
+                    <a:p>
+                      <a:pPr>
+                        <a:defRPr sz="1900">
+                          <a:solidFill>
+                            <a:srgbClr val="192B40"/>
+                          </a:solidFill>
+                        </a:defRPr>
+                      </a:pPr>
+                      <a:r>
+                        <a:t>1</a:t>
+                      </a:r>
+                    </a:p>
+                  </a:txBody>
+                  <a:tcPr>
+                    <a:solidFill>
+                      <a:srgbClr val="F4DDCE"/>
+                    </a:solidFill>
+                  </a:tcPr>
+                </a:tc>
+                <a:tc>
+                  <a:txBody>
+                    <a:bodyPr/>
+                    <a:lstStyle/>
+                    <a:p>
+                      <a:pPr>
+                        <a:defRPr sz="1900">
+                          <a:solidFill>
+                            <a:srgbClr val="192B40"/>
+                          </a:solidFill>
+                        </a:defRPr>
+                      </a:pPr>
+                      <a:r>
+                        <a:t>Listen and sketch</a:t>
+                      </a:r>
+                    </a:p>
+                  </a:txBody>
+                  <a:tcPr>
+                    <a:solidFill>
+                      <a:srgbClr val="F4DDCE"/>
+                    </a:solidFill>
+                  </a:tcPr>
+                </a:tc>
+                <a:tc>
+                  <a:txBody>
+                    <a:bodyPr/>
+                    <a:lstStyle/>
+                    <a:p>
+                      <a:pPr>
+                        <a:defRPr sz="1900">
+                          <a:solidFill>
+                            <a:srgbClr val="192B40"/>
+                          </a:solidFill>
+                        </a:defRPr>
+                      </a:pPr>
+                      <a:r>
+                        <a:t>Neighbors</a:t>
+                      </a:r>
+                    </a:p>
+                  </a:txBody>
+                  <a:tcPr>
+                    <a:solidFill>
+                      <a:srgbClr val="F4DDCE"/>
+                    </a:solidFill>
+                  </a:tcPr>
+                </a:tc>
+                <a:tc>
+                  <a:txBody>
+                    <a:bodyPr/>
+                    <a:lstStyle/>
+                    <a:p>
+                      <a:pPr>
+                        <a:defRPr sz="1900">
+                          <a:solidFill>
+                            <a:srgbClr val="192B40"/>
+                          </a:solidFill>
+                        </a:defRPr>
+                      </a:pPr>
+                      <a:r>
+                        <a:t>A shared plan</a:t>
+                      </a:r>
+                    </a:p>
+                  </a:txBody>
+                  <a:tcPr>
+                    <a:solidFill>
+                      <a:srgbClr val="F4DDCE"/>
+                    </a:solidFill>
+                  </a:tcPr>
+                </a:tc>
+              </a:tr>
+              <a:tr h="694944">
+                <a:tc>
+                  <a:txBody>
+                    <a:bodyPr/>
+                    <a:lstStyle/>
+                    <a:p>
+                      <a:pPr>
+                        <a:defRPr sz="1900">
+                          <a:solidFill>
+                            <a:srgbClr val="192B40"/>
+                          </a:solidFill>
+                        </a:defRPr>
+                      </a:pPr>
+                      <a:r>
+                        <a:t>2</a:t>
+                      </a:r>
+                    </a:p>
+                  </a:txBody>
+                  <a:tcPr>
+                    <a:solidFill>
+                      <a:srgbClr val="FFF6EF"/>
+                    </a:solidFill>
+                  </a:tcPr>
+                </a:tc>
+                <a:tc>
+                  <a:txBody>
+                    <a:bodyPr/>
+                    <a:lstStyle/>
+                    <a:p>
+                      <a:pPr>
+                        <a:defRPr sz="1900">
+                          <a:solidFill>
+                            <a:srgbClr val="192B40"/>
+                          </a:solidFill>
+                        </a:defRPr>
+                      </a:pPr>
+                      <a:r>
+                        <a:t>Build beds and paths</a:t>
+                      </a:r>
+                    </a:p>
+                  </a:txBody>
+                  <a:tcPr>
+                    <a:solidFill>
+                      <a:srgbClr val="FFF6EF"/>
+                    </a:solidFill>
+                  </a:tcPr>
+                </a:tc>
+                <a:tc>
+                  <a:txBody>
+                    <a:bodyPr/>
+                    <a:lstStyle/>
+                    <a:p>
+                      <a:pPr>
+                        <a:defRPr sz="1900">
+                          <a:solidFill>
+                            <a:srgbClr val="192B40"/>
+                          </a:solidFill>
+                        </a:defRPr>
+                      </a:pPr>
+                      <a:r>
+                        <a:t>Build team</a:t>
+                      </a:r>
+                    </a:p>
+                  </a:txBody>
+                  <a:tcPr>
+                    <a:solidFill>
+                      <a:srgbClr val="FFF6EF"/>
+                    </a:solidFill>
+                  </a:tcPr>
+                </a:tc>
+                <a:tc>
+                  <a:txBody>
+                    <a:bodyPr/>
+                    <a:lstStyle/>
+                    <a:p>
+                      <a:pPr>
+                        <a:defRPr sz="1900">
+                          <a:solidFill>
+                            <a:srgbClr val="192B40"/>
+                          </a:solidFill>
+                        </a:defRPr>
+                      </a:pPr>
+                      <a:r>
+                        <a:t>A welcoming space</a:t>
+                      </a:r>
+                    </a:p>
+                  </a:txBody>
+                  <a:tcPr>
+                    <a:solidFill>
+                      <a:srgbClr val="FFF6EF"/>
+                    </a:solidFill>
+                  </a:tcPr>
+                </a:tc>
+              </a:tr>
+              <a:tr h="694944">
+                <a:tc>
+                  <a:txBody>
+                    <a:bodyPr/>
+                    <a:lstStyle/>
+                    <a:p>
+                      <a:pPr>
+                        <a:defRPr sz="1900">
+                          <a:solidFill>
+                            <a:srgbClr val="192B40"/>
+                          </a:solidFill>
+                        </a:defRPr>
+                      </a:pPr>
+                      <a:r>
+                        <a:t>3</a:t>
+                      </a:r>
+                    </a:p>
+                  </a:txBody>
+                  <a:tcPr>
+                    <a:solidFill>
+                      <a:srgbClr val="F4DDCE"/>
+                    </a:solidFill>
+                  </a:tcPr>
+                </a:tc>
+                <a:tc>
+                  <a:txBody>
+                    <a:bodyPr/>
+                    <a:lstStyle/>
+                    <a:p>
+                      <a:pPr>
+                        <a:defRPr sz="1900">
+                          <a:solidFill>
+                            <a:srgbClr val="192B40"/>
+                          </a:solidFill>
+                        </a:defRPr>
+                      </a:pPr>
+                      <a:r>
+                        <a:t>Plant and label</a:t>
+                      </a:r>
+                    </a:p>
+                  </a:txBody>
+                  <a:tcPr>
+                    <a:solidFill>
+                      <a:srgbClr val="F4DDCE"/>
+                    </a:solidFill>
+                  </a:tcPr>
+                </a:tc>
+                <a:tc>
+                  <a:txBody>
+                    <a:bodyPr/>
+                    <a:lstStyle/>
+                    <a:p>
+                      <a:pPr>
+                        <a:defRPr sz="1900">
+                          <a:solidFill>
+                            <a:srgbClr val="192B40"/>
+                          </a:solidFill>
+                        </a:defRPr>
+                      </a:pPr>
+                      <a:r>
+                        <a:t>Garden team</a:t>
+                      </a:r>
+                    </a:p>
+                  </a:txBody>
+                  <a:tcPr>
+                    <a:solidFill>
+                      <a:srgbClr val="F4DDCE"/>
+                    </a:solidFill>
+                  </a:tcPr>
+                </a:tc>
+                <a:tc>
+                  <a:txBody>
+                    <a:bodyPr/>
+                    <a:lstStyle/>
+                    <a:p>
+                      <a:pPr>
+                        <a:defRPr sz="1900">
+                          <a:solidFill>
+                            <a:srgbClr val="192B40"/>
+                          </a:solidFill>
+                        </a:defRPr>
+                      </a:pPr>
+                      <a:r>
+                        <a:t>The first seedlings</a:t>
+                      </a:r>
+                    </a:p>
+                  </a:txBody>
+                  <a:tcPr>
+                    <a:solidFill>
+                      <a:srgbClr val="F4DDCE"/>
+                    </a:solidFill>
+                  </a:tcPr>
+                </a:tc>
+              </a:tr>
+              <a:tr h="694944">
+                <a:tc>
+                  <a:txBody>
+                    <a:bodyPr/>
+                    <a:lstStyle/>
+                    <a:p>
+                      <a:pPr>
+                        <a:defRPr sz="1900">
+                          <a:solidFill>
+                            <a:srgbClr val="192B40"/>
+                          </a:solidFill>
+                        </a:defRPr>
+                      </a:pPr>
+                      <a:r>
+                        <a:t>4</a:t>
+                      </a:r>
+                    </a:p>
+                  </a:txBody>
+                  <a:tcPr>
+                    <a:solidFill>
+                      <a:srgbClr val="FFF6EF"/>
+                    </a:solidFill>
+                  </a:tcPr>
+                </a:tc>
+                <a:tc>
+                  <a:txBody>
+                    <a:bodyPr/>
+                    <a:lstStyle/>
+                    <a:p>
+                      <a:pPr>
+                        <a:defRPr sz="1900">
+                          <a:solidFill>
+                            <a:srgbClr val="192B40"/>
+                          </a:solidFill>
+                        </a:defRPr>
+                      </a:pPr>
+                      <a:r>
+                        <a:t>Open the gates</a:t>
+                      </a:r>
+                    </a:p>
+                  </a:txBody>
+                  <a:tcPr>
+                    <a:solidFill>
+                      <a:srgbClr val="FFF6EF"/>
+                    </a:solidFill>
+                  </a:tcPr>
+                </a:tc>
+                <a:tc>
+                  <a:txBody>
+                    <a:bodyPr/>
+                    <a:lstStyle/>
+                    <a:p>
+                      <a:pPr>
+                        <a:defRPr sz="1900">
+                          <a:solidFill>
+                            <a:srgbClr val="192B40"/>
+                          </a:solidFill>
+                        </a:defRPr>
+                      </a:pPr>
+                      <a:r>
+                        <a:t>Everyone</a:t>
+                      </a:r>
+                    </a:p>
+                  </a:txBody>
+                  <a:tcPr>
+                    <a:solidFill>
+                      <a:srgbClr val="FFF6EF"/>
+                    </a:solidFill>
+                  </a:tcPr>
+                </a:tc>
+                <a:tc>
+                  <a:txBody>
+                    <a:bodyPr/>
+                    <a:lstStyle/>
+                    <a:p>
+                      <a:pPr>
+                        <a:defRPr sz="1900">
+                          <a:solidFill>
+                            <a:srgbClr val="192B40"/>
+                          </a:solidFill>
+                        </a:defRPr>
+                      </a:pPr>
+                      <a:r>
+                        <a:t>A new habit</a:t>
+                      </a:r>
+                    </a:p>
+                  </a:txBody>
+                  <a:tcPr>
+                    <a:solidFill>
+                      <a:srgbClr val="FFF6EF"/>
+                    </a:solidFill>
+                  </a:tcPr>
+                </a:tc>
+              </a:tr>
+            </a:tbl>
+          </a:graphicData>
+        </a:graphic>
+      </p:graphicFrame>
+    </p:spTree>
+  </p:cSld>
+  <p:clrMapOvr>
+    <a:masterClrMapping/>
+  </p:clrMapOvr>
+</p:sld>
+</file>
+
+<file path=ppt/slides/slide5.xml><?xml version="1.0" encoding="utf-8"?>
+<p:sld xmlns:a="http://schemas.openxmlformats.org/drawingml/2006/main" xmlns:p="http://schemas.openxmlformats.org/presentationml/2006/main" xmlns:r="http://schemas.openxmlformats.org/officeDocument/2006/relationships">
+  <p:cSld>
+    <p:bg>
+      <p:bgPr>
+        <a:solidFill>
+          <a:srgbClr val="FFF6EF"/>
+        </a:solidFill>
+        <a:effectLst/>
+      </p:bgPr>
+    </p:bg>
+    <p:spTree>
+      <p:nvGrpSpPr>
+        <p:cNvPr id="1" name=""/>
+        <p:cNvGrpSpPr/>
+        <p:nvPr/>
+      </p:nvGrpSpPr>
+      <p:grpSpPr/>
+      <p:sp>
+        <p:nvSpPr>
+          <p:cNvPr id="2" name="Rectangle 1"/>
+          <p:cNvSpPr/>
+          <p:nvPr/>
+        </p:nvSpPr>
+        <p:spPr>
+          <a:xfrm>
+            <a:off x="0" y="0"/>
+            <a:ext cx="146304" cy="6858000"/>
+          </a:xfrm>
+          <a:prstGeom prst="rect">
+            <a:avLst/>
+          </a:prstGeom>
+          <a:solidFill>
+            <a:srgbClr val="DC623D"/>
+          </a:solidFill>
+          <a:ln>
+            <a:noFill/>
+          </a:ln>
+        </p:spPr>
+        <p:style>
+          <a:lnRef idx="1">
+            <a:schemeClr val="accent1"/>
+          </a:lnRef>
+          <a:fillRef idx="3">
+            <a:schemeClr val="accent1"/>
+          </a:fillRef>
+          <a:effectRef idx="2">
+            <a:schemeClr val="accent1"/>
+          </a:effectRef>
+          <a:fontRef idx="minor">
+            <a:schemeClr val="lt1"/>
+          </a:fontRef>
+        </p:style>
+        <p:txBody>
+          <a:bodyPr rtlCol="0" anchor="ctr"/>
+          <a:lstStyle/>
+          <a:p>
+            <a:pPr algn="ctr"/>
+          </a:p>
+        </p:txBody>
+      </p:sp>
+      <p:sp>
+        <p:nvSpPr>
+          <p:cNvPr id="3" name="TextBox 2"/>
+          <p:cNvSpPr txBox="1"/>
+          <p:nvPr/>
+        </p:nvSpPr>
+        <p:spPr>
+          <a:xfrm>
+            <a:off x="594360" y="320040"/>
+            <a:ext cx="10972800" cy="457200"/>
+          </a:xfrm>
+          <a:prstGeom prst="rect">
+            <a:avLst/>
+          </a:prstGeom>
+          <a:noFill/>
+        </p:spPr>
+        <p:txBody>
+          <a:bodyPr wrap="square">
+            <a:spAutoFit/>
+          </a:bodyPr>
+          <a:lstStyle/>
+          <a:p>
+            <a:pPr>
+              <a:defRPr sz="1200" b="1">
+                <a:solidFill>
+                  <a:srgbClr val="AC4328"/>
+                </a:solidFill>
+                <a:latin typeface="Calibri"/>
+              </a:defRPr>
+            </a:pPr>
+            <a:r>
+              <a:t>FIELD NOTES / COMMUNITY GARDEN   /   05</a:t>
+            </a:r>
+          </a:p>
+        </p:txBody>
+      </p:sp>
+      <p:sp>
+        <p:nvSpPr>
+          <p:cNvPr id="4" name="TextBox 3"/>
+          <p:cNvSpPr txBox="1"/>
+          <p:nvPr/>
+        </p:nvSpPr>
+        <p:spPr>
+          <a:xfrm>
+            <a:off x="594360" y="960120"/>
+            <a:ext cx="10972800" cy="914400"/>
+          </a:xfrm>
+          <a:prstGeom prst="rect">
+            <a:avLst/>
+          </a:prstGeom>
+          <a:noFill/>
+        </p:spPr>
+        <p:txBody>
+          <a:bodyPr wrap="square">
+            <a:spAutoFit/>
+          </a:bodyPr>
+          <a:lstStyle/>
+          <a:p>
+            <a:pPr>
+              <a:defRPr sz="3200" b="1">
                 <a:solidFill>
                   <a:srgbClr val="192B40"/>
                 </a:solidFill>
@@ -4604,6 +7286,997 @@
               </a:defRPr>
             </a:pPr>
             <a:r>
+              <a:t>Learn. Share. Grow.</a:t>
+            </a:r>
+          </a:p>
+        </p:txBody>
+      </p:sp>
+      <p:sp>
+        <p:nvSpPr>
+          <p:cNvPr id="5" name="TextBox 4"/>
+          <p:cNvSpPr txBox="1"/>
+          <p:nvPr/>
+        </p:nvSpPr>
+        <p:spPr>
+          <a:xfrm>
+            <a:off x="594360" y="6263640"/>
+            <a:ext cx="10972800" cy="365760"/>
+          </a:xfrm>
+          <a:prstGeom prst="rect">
+            <a:avLst/>
+          </a:prstGeom>
+          <a:noFill/>
+        </p:spPr>
+        <p:txBody>
+          <a:bodyPr wrap="square">
+            <a:spAutoFit/>
+          </a:bodyPr>
+          <a:lstStyle/>
+          <a:p>
+            <a:pPr>
+              <a:defRPr sz="1200" b="0">
+                <a:solidFill>
+                  <a:srgbClr val="AC4328"/>
+                </a:solidFill>
+                <a:latin typeface="Calibri"/>
+              </a:defRPr>
+            </a:pPr>
+            <a:r>
+              <a:t>Try it: select the SmartArt diagram, move or resize it, then save and reopen the deck.</a:t>
+            </a:r>
+          </a:p>
+        </p:txBody>
+      </p:sp>
+      <p:graphicFrame>
+        <p:nvGraphicFramePr>
+          <p:cNvPr id="6" name="Table 5"/>
+          <p:cNvGraphicFramePr>
+            <a:graphicFrameLocks noGrp="1"/>
+          </p:cNvGraphicFramePr>
+          <p:nvPr/>
+        </p:nvGraphicFramePr>
+        <p:xfrm>
+          <a:off x="640080" y="2240280"/>
+          <a:ext cx="10881360" cy="3200400"/>
+        </p:xfrm>
+        <a:graphic>
+          <a:graphicData uri="http://schemas.openxmlformats.org/drawingml/2006/diagram">
+            <dgm:relIds xmlns:dgm="http://schemas.openxmlformats.org/drawingml/2006/diagram" r:dm="rIdGardenData" r:lo="rIdGardenLayout" r:qs="rIdGardenStyle" r:cs="rIdGardenColors"/>
+          </a:graphicData>
+        </a:graphic>
+      </p:graphicFrame>
+    </p:spTree>
+  </p:cSld>
+  <p:clrMapOvr>
+    <a:masterClrMapping/>
+  </p:clrMapOvr>
+</p:sld>
+</file>
+
+<file path=ppt/slides/slide6.xml><?xml version="1.0" encoding="utf-8"?>
+<p:sld xmlns:a="http://schemas.openxmlformats.org/drawingml/2006/main" xmlns:p="http://schemas.openxmlformats.org/presentationml/2006/main" xmlns:r="http://schemas.openxmlformats.org/officeDocument/2006/relationships">
+  <p:cSld>
+    <p:bg>
+      <p:bgPr>
+        <a:solidFill>
+          <a:srgbClr val="FFF6EF"/>
+        </a:solidFill>
+        <a:effectLst/>
+      </p:bgPr>
+    </p:bg>
+    <p:spTree>
+      <p:nvGrpSpPr>
+        <p:cNvPr id="1" name=""/>
+        <p:cNvGrpSpPr/>
+        <p:nvPr/>
+      </p:nvGrpSpPr>
+      <p:grpSpPr/>
+      <p:sp>
+        <p:nvSpPr>
+          <p:cNvPr id="2" name="Rectangle 1"/>
+          <p:cNvSpPr/>
+          <p:nvPr/>
+        </p:nvSpPr>
+        <p:spPr>
+          <a:xfrm>
+            <a:off x="0" y="0"/>
+            <a:ext cx="146304" cy="6858000"/>
+          </a:xfrm>
+          <a:prstGeom prst="rect">
+            <a:avLst/>
+          </a:prstGeom>
+          <a:solidFill>
+            <a:srgbClr val="DC623D"/>
+          </a:solidFill>
+          <a:ln>
+            <a:noFill/>
+          </a:ln>
+        </p:spPr>
+        <p:style>
+          <a:lnRef idx="1">
+            <a:schemeClr val="accent1"/>
+          </a:lnRef>
+          <a:fillRef idx="3">
+            <a:schemeClr val="accent1"/>
+          </a:fillRef>
+          <a:effectRef idx="2">
+            <a:schemeClr val="accent1"/>
+          </a:effectRef>
+          <a:fontRef idx="minor">
+            <a:schemeClr val="lt1"/>
+          </a:fontRef>
+        </p:style>
+        <p:txBody>
+          <a:bodyPr rtlCol="0" anchor="ctr"/>
+          <a:lstStyle/>
+          <a:p>
+            <a:pPr algn="ctr"/>
+          </a:p>
+        </p:txBody>
+      </p:sp>
+      <p:sp>
+        <p:nvSpPr>
+          <p:cNvPr id="3" name="TextBox 2"/>
+          <p:cNvSpPr txBox="1"/>
+          <p:nvPr/>
+        </p:nvSpPr>
+        <p:spPr>
+          <a:xfrm>
+            <a:off x="594360" y="320040"/>
+            <a:ext cx="10972800" cy="457200"/>
+          </a:xfrm>
+          <a:prstGeom prst="rect">
+            <a:avLst/>
+          </a:prstGeom>
+          <a:noFill/>
+        </p:spPr>
+        <p:txBody>
+          <a:bodyPr wrap="square">
+            <a:spAutoFit/>
+          </a:bodyPr>
+          <a:lstStyle/>
+          <a:p>
+            <a:pPr>
+              <a:defRPr sz="1200" b="1">
+                <a:solidFill>
+                  <a:srgbClr val="AC4328"/>
+                </a:solidFill>
+                <a:latin typeface="Calibri"/>
+              </a:defRPr>
+            </a:pPr>
+            <a:r>
+              <a:t>FIELD NOTES / COMMUNITY GARDEN   /   06</a:t>
+            </a:r>
+          </a:p>
+        </p:txBody>
+      </p:sp>
+      <p:sp>
+        <p:nvSpPr>
+          <p:cNvPr id="4" name="TextBox 3"/>
+          <p:cNvSpPr txBox="1"/>
+          <p:nvPr/>
+        </p:nvSpPr>
+        <p:spPr>
+          <a:xfrm>
+            <a:off x="594360" y="960120"/>
+            <a:ext cx="10972800" cy="914400"/>
+          </a:xfrm>
+          <a:prstGeom prst="rect">
+            <a:avLst/>
+          </a:prstGeom>
+          <a:noFill/>
+        </p:spPr>
+        <p:txBody>
+          <a:bodyPr wrap="square">
+            <a:spAutoFit/>
+          </a:bodyPr>
+          <a:lstStyle/>
+          <a:p>
+            <a:pPr>
+              <a:defRPr sz="3200" b="1">
+                <a:solidFill>
+                  <a:srgbClr val="192B40"/>
+                </a:solidFill>
+                <a:latin typeface="Calibri"/>
+              </a:defRPr>
+            </a:pPr>
+            <a:r>
+              <a:t>A season of small gains.</a:t>
+            </a:r>
+          </a:p>
+        </p:txBody>
+      </p:sp>
+      <p:sp>
+        <p:nvSpPr>
+          <p:cNvPr id="5" name="TextBox 4"/>
+          <p:cNvSpPr txBox="1"/>
+          <p:nvPr/>
+        </p:nvSpPr>
+        <p:spPr>
+          <a:xfrm>
+            <a:off x="594360" y="6263640"/>
+            <a:ext cx="10972800" cy="365760"/>
+          </a:xfrm>
+          <a:prstGeom prst="rect">
+            <a:avLst/>
+          </a:prstGeom>
+          <a:noFill/>
+        </p:spPr>
+        <p:txBody>
+          <a:bodyPr wrap="square">
+            <a:spAutoFit/>
+          </a:bodyPr>
+          <a:lstStyle/>
+          <a:p>
+            <a:pPr>
+              <a:defRPr sz="1200" b="0">
+                <a:solidFill>
+                  <a:srgbClr val="AC4328"/>
+                </a:solidFill>
+                <a:latin typeface="Calibri"/>
+              </a:defRPr>
+            </a:pPr>
+            <a:r>
+              <a:t>Try it: change the line and area chart values to explore a different season.</a:t>
+            </a:r>
+          </a:p>
+        </p:txBody>
+      </p:sp>
+      <p:graphicFrame>
+        <p:nvGraphicFramePr>
+          <p:cNvPr id="6" name="Chart 5"/>
+          <p:cNvGraphicFramePr>
+            <a:graphicFrameLocks noGrp="1"/>
+          </p:cNvGraphicFramePr>
+          <p:nvPr/>
+        </p:nvGraphicFramePr>
+        <p:xfrm>
+          <a:off x="548640" y="1965960"/>
+          <a:ext cx="5486400" cy="3931920"/>
+        </p:xfrm>
+        <a:graphic>
+          <a:graphicData uri="http://schemas.openxmlformats.org/drawingml/2006/chart">
+            <c:chart xmlns:c="http://schemas.openxmlformats.org/drawingml/2006/chart" r:id="rId3"/>
+          </a:graphicData>
+        </a:graphic>
+      </p:graphicFrame>
+      <p:graphicFrame>
+        <p:nvGraphicFramePr>
+          <p:cNvPr id="7" name="Chart 6"/>
+          <p:cNvGraphicFramePr>
+            <a:graphicFrameLocks noGrp="1"/>
+          </p:cNvGraphicFramePr>
+          <p:nvPr/>
+        </p:nvGraphicFramePr>
+        <p:xfrm>
+          <a:off x="6217920" y="1965960"/>
+          <a:ext cx="5394960" cy="3931920"/>
+        </p:xfrm>
+        <a:graphic>
+          <a:graphicData uri="http://schemas.openxmlformats.org/drawingml/2006/chart">
+            <c:chart xmlns:c="http://schemas.openxmlformats.org/drawingml/2006/chart" r:id="rId4"/>
+          </a:graphicData>
+        </a:graphic>
+      </p:graphicFrame>
+    </p:spTree>
+  </p:cSld>
+  <p:clrMapOvr>
+    <a:masterClrMapping/>
+  </p:clrMapOvr>
+</p:sld>
+</file>
+
+<file path=ppt/slides/slide7.xml><?xml version="1.0" encoding="utf-8"?>
+<p:sld xmlns:a="http://schemas.openxmlformats.org/drawingml/2006/main" xmlns:p="http://schemas.openxmlformats.org/presentationml/2006/main" xmlns:r="http://schemas.openxmlformats.org/officeDocument/2006/relationships">
+  <p:cSld>
+    <p:bg>
+      <p:bgPr>
+        <a:solidFill>
+          <a:srgbClr val="FFF6EF"/>
+        </a:solidFill>
+        <a:effectLst/>
+      </p:bgPr>
+    </p:bg>
+    <p:spTree>
+      <p:nvGrpSpPr>
+        <p:cNvPr id="1" name=""/>
+        <p:cNvGrpSpPr/>
+        <p:nvPr/>
+      </p:nvGrpSpPr>
+      <p:grpSpPr/>
+      <p:sp>
+        <p:nvSpPr>
+          <p:cNvPr id="2" name="Rectangle 1"/>
+          <p:cNvSpPr/>
+          <p:nvPr/>
+        </p:nvSpPr>
+        <p:spPr>
+          <a:xfrm>
+            <a:off x="0" y="0"/>
+            <a:ext cx="146304" cy="6858000"/>
+          </a:xfrm>
+          <a:prstGeom prst="rect">
+            <a:avLst/>
+          </a:prstGeom>
+          <a:solidFill>
+            <a:srgbClr val="DC623D"/>
+          </a:solidFill>
+          <a:ln>
+            <a:noFill/>
+          </a:ln>
+        </p:spPr>
+        <p:style>
+          <a:lnRef idx="1">
+            <a:schemeClr val="accent1"/>
+          </a:lnRef>
+          <a:fillRef idx="3">
+            <a:schemeClr val="accent1"/>
+          </a:fillRef>
+          <a:effectRef idx="2">
+            <a:schemeClr val="accent1"/>
+          </a:effectRef>
+          <a:fontRef idx="minor">
+            <a:schemeClr val="lt1"/>
+          </a:fontRef>
+        </p:style>
+        <p:txBody>
+          <a:bodyPr rtlCol="0" anchor="ctr"/>
+          <a:lstStyle/>
+          <a:p>
+            <a:pPr algn="ctr"/>
+          </a:p>
+        </p:txBody>
+      </p:sp>
+      <p:sp>
+        <p:nvSpPr>
+          <p:cNvPr id="3" name="TextBox 2"/>
+          <p:cNvSpPr txBox="1"/>
+          <p:nvPr/>
+        </p:nvSpPr>
+        <p:spPr>
+          <a:xfrm>
+            <a:off x="594360" y="320040"/>
+            <a:ext cx="10972800" cy="457200"/>
+          </a:xfrm>
+          <a:prstGeom prst="rect">
+            <a:avLst/>
+          </a:prstGeom>
+          <a:noFill/>
+        </p:spPr>
+        <p:txBody>
+          <a:bodyPr wrap="square">
+            <a:spAutoFit/>
+          </a:bodyPr>
+          <a:lstStyle/>
+          <a:p>
+            <a:pPr>
+              <a:defRPr sz="1200" b="1">
+                <a:solidFill>
+                  <a:srgbClr val="AC4328"/>
+                </a:solidFill>
+                <a:latin typeface="Calibri"/>
+              </a:defRPr>
+            </a:pPr>
+            <a:r>
+              <a:t>FIELD NOTES / COMMUNITY GARDEN   /   07</a:t>
+            </a:r>
+          </a:p>
+        </p:txBody>
+      </p:sp>
+      <p:sp>
+        <p:nvSpPr>
+          <p:cNvPr id="4" name="TextBox 3"/>
+          <p:cNvSpPr txBox="1"/>
+          <p:nvPr/>
+        </p:nvSpPr>
+        <p:spPr>
+          <a:xfrm>
+            <a:off x="594360" y="960120"/>
+            <a:ext cx="10972800" cy="914400"/>
+          </a:xfrm>
+          <a:prstGeom prst="rect">
+            <a:avLst/>
+          </a:prstGeom>
+          <a:noFill/>
+        </p:spPr>
+        <p:txBody>
+          <a:bodyPr wrap="square">
+            <a:spAutoFit/>
+          </a:bodyPr>
+          <a:lstStyle/>
+          <a:p>
+            <a:pPr>
+              <a:defRPr sz="3200" b="1">
+                <a:solidFill>
+                  <a:srgbClr val="192B40"/>
+                </a:solidFill>
+                <a:latin typeface="Calibri"/>
+              </a:defRPr>
+            </a:pPr>
+            <a:r>
+              <a:t>See the balance.</a:t>
+            </a:r>
+          </a:p>
+        </p:txBody>
+      </p:sp>
+      <p:sp>
+        <p:nvSpPr>
+          <p:cNvPr id="5" name="TextBox 4"/>
+          <p:cNvSpPr txBox="1"/>
+          <p:nvPr/>
+        </p:nvSpPr>
+        <p:spPr>
+          <a:xfrm>
+            <a:off x="594360" y="6263640"/>
+            <a:ext cx="10972800" cy="365760"/>
+          </a:xfrm>
+          <a:prstGeom prst="rect">
+            <a:avLst/>
+          </a:prstGeom>
+          <a:noFill/>
+        </p:spPr>
+        <p:txBody>
+          <a:bodyPr wrap="square">
+            <a:spAutoFit/>
+          </a:bodyPr>
+          <a:lstStyle/>
+          <a:p>
+            <a:pPr>
+              <a:defRPr sz="1200" b="0">
+                <a:solidFill>
+                  <a:srgbClr val="AC4328"/>
+                </a:solidFill>
+                <a:latin typeface="Calibri"/>
+              </a:defRPr>
+            </a:pPr>
+            <a:r>
+              <a:t>Try it: compare a bar chart with a pie chart. Change the chart colors and labels.</a:t>
+            </a:r>
+          </a:p>
+        </p:txBody>
+      </p:sp>
+      <p:graphicFrame>
+        <p:nvGraphicFramePr>
+          <p:cNvPr id="6" name="Chart 5"/>
+          <p:cNvGraphicFramePr>
+            <a:graphicFrameLocks noGrp="1"/>
+          </p:cNvGraphicFramePr>
+          <p:nvPr/>
+        </p:nvGraphicFramePr>
+        <p:xfrm>
+          <a:off x="548640" y="1965960"/>
+          <a:ext cx="5486400" cy="3931920"/>
+        </p:xfrm>
+        <a:graphic>
+          <a:graphicData uri="http://schemas.openxmlformats.org/drawingml/2006/chart">
+            <c:chart xmlns:c="http://schemas.openxmlformats.org/drawingml/2006/chart" r:id="rId3"/>
+          </a:graphicData>
+        </a:graphic>
+      </p:graphicFrame>
+      <p:graphicFrame>
+        <p:nvGraphicFramePr>
+          <p:cNvPr id="7" name="Chart 6"/>
+          <p:cNvGraphicFramePr>
+            <a:graphicFrameLocks noGrp="1"/>
+          </p:cNvGraphicFramePr>
+          <p:nvPr/>
+        </p:nvGraphicFramePr>
+        <p:xfrm>
+          <a:off x="6217920" y="1965960"/>
+          <a:ext cx="5394960" cy="3931920"/>
+        </p:xfrm>
+        <a:graphic>
+          <a:graphicData uri="http://schemas.openxmlformats.org/drawingml/2006/chart">
+            <c:chart xmlns:c="http://schemas.openxmlformats.org/drawingml/2006/chart" r:id="rId4"/>
+          </a:graphicData>
+        </a:graphic>
+      </p:graphicFrame>
+    </p:spTree>
+  </p:cSld>
+  <p:clrMapOvr>
+    <a:masterClrMapping/>
+  </p:clrMapOvr>
+</p:sld>
+</file>
+
+<file path=ppt/slides/slide8.xml><?xml version="1.0" encoding="utf-8"?>
+<p:sld xmlns:a="http://schemas.openxmlformats.org/drawingml/2006/main" xmlns:p="http://schemas.openxmlformats.org/presentationml/2006/main" xmlns:r="http://schemas.openxmlformats.org/officeDocument/2006/relationships">
+  <p:cSld>
+    <p:bg>
+      <p:bgPr>
+        <a:solidFill>
+          <a:srgbClr val="FFF6EF"/>
+        </a:solidFill>
+        <a:effectLst/>
+      </p:bgPr>
+    </p:bg>
+    <p:spTree>
+      <p:nvGrpSpPr>
+        <p:cNvPr id="1" name=""/>
+        <p:cNvGrpSpPr/>
+        <p:nvPr/>
+      </p:nvGrpSpPr>
+      <p:grpSpPr/>
+      <p:sp>
+        <p:nvSpPr>
+          <p:cNvPr id="2" name="Rectangle 1"/>
+          <p:cNvSpPr/>
+          <p:nvPr/>
+        </p:nvSpPr>
+        <p:spPr>
+          <a:xfrm>
+            <a:off x="0" y="0"/>
+            <a:ext cx="146304" cy="6858000"/>
+          </a:xfrm>
+          <a:prstGeom prst="rect">
+            <a:avLst/>
+          </a:prstGeom>
+          <a:solidFill>
+            <a:srgbClr val="DC623D"/>
+          </a:solidFill>
+          <a:ln>
+            <a:noFill/>
+          </a:ln>
+        </p:spPr>
+        <p:style>
+          <a:lnRef idx="1">
+            <a:schemeClr val="accent1"/>
+          </a:lnRef>
+          <a:fillRef idx="3">
+            <a:schemeClr val="accent1"/>
+          </a:fillRef>
+          <a:effectRef idx="2">
+            <a:schemeClr val="accent1"/>
+          </a:effectRef>
+          <a:fontRef idx="minor">
+            <a:schemeClr val="lt1"/>
+          </a:fontRef>
+        </p:style>
+        <p:txBody>
+          <a:bodyPr rtlCol="0" anchor="ctr"/>
+          <a:lstStyle/>
+          <a:p>
+            <a:pPr algn="ctr"/>
+          </a:p>
+        </p:txBody>
+      </p:sp>
+      <p:sp>
+        <p:nvSpPr>
+          <p:cNvPr id="3" name="TextBox 2"/>
+          <p:cNvSpPr txBox="1"/>
+          <p:nvPr/>
+        </p:nvSpPr>
+        <p:spPr>
+          <a:xfrm>
+            <a:off x="594360" y="320040"/>
+            <a:ext cx="10972800" cy="457200"/>
+          </a:xfrm>
+          <a:prstGeom prst="rect">
+            <a:avLst/>
+          </a:prstGeom>
+          <a:noFill/>
+        </p:spPr>
+        <p:txBody>
+          <a:bodyPr wrap="square">
+            <a:spAutoFit/>
+          </a:bodyPr>
+          <a:lstStyle/>
+          <a:p>
+            <a:pPr>
+              <a:defRPr sz="1200" b="1">
+                <a:solidFill>
+                  <a:srgbClr val="AC4328"/>
+                </a:solidFill>
+                <a:latin typeface="Calibri"/>
+              </a:defRPr>
+            </a:pPr>
+            <a:r>
+              <a:t>FIELD NOTES / COMMUNITY GARDEN   /   08</a:t>
+            </a:r>
+          </a:p>
+        </p:txBody>
+      </p:sp>
+      <p:sp>
+        <p:nvSpPr>
+          <p:cNvPr id="4" name="TextBox 3"/>
+          <p:cNvSpPr txBox="1"/>
+          <p:nvPr/>
+        </p:nvSpPr>
+        <p:spPr>
+          <a:xfrm>
+            <a:off x="594360" y="960120"/>
+            <a:ext cx="10972800" cy="914400"/>
+          </a:xfrm>
+          <a:prstGeom prst="rect">
+            <a:avLst/>
+          </a:prstGeom>
+          <a:noFill/>
+        </p:spPr>
+        <p:txBody>
+          <a:bodyPr wrap="square">
+            <a:spAutoFit/>
+          </a:bodyPr>
+          <a:lstStyle/>
+          <a:p>
+            <a:pPr>
+              <a:defRPr sz="3200" b="1">
+                <a:solidFill>
+                  <a:srgbClr val="192B40"/>
+                </a:solidFill>
+                <a:latin typeface="Calibri"/>
+              </a:defRPr>
+            </a:pPr>
+            <a:r>
+              <a:t>Look for a pattern.</a:t>
+            </a:r>
+          </a:p>
+        </p:txBody>
+      </p:sp>
+      <p:sp>
+        <p:nvSpPr>
+          <p:cNvPr id="5" name="TextBox 4"/>
+          <p:cNvSpPr txBox="1"/>
+          <p:nvPr/>
+        </p:nvSpPr>
+        <p:spPr>
+          <a:xfrm>
+            <a:off x="594360" y="6263640"/>
+            <a:ext cx="10972800" cy="365760"/>
+          </a:xfrm>
+          <a:prstGeom prst="rect">
+            <a:avLst/>
+          </a:prstGeom>
+          <a:noFill/>
+        </p:spPr>
+        <p:txBody>
+          <a:bodyPr wrap="square">
+            <a:spAutoFit/>
+          </a:bodyPr>
+          <a:lstStyle/>
+          <a:p>
+            <a:pPr>
+              <a:defRPr sz="1200" b="0">
+                <a:solidFill>
+                  <a:srgbClr val="AC4328"/>
+                </a:solidFill>
+                <a:latin typeface="Calibri"/>
+              </a:defRPr>
+            </a:pPr>
+            <a:r>
+              <a:t>Try it: edit a scatter plot point or a doughnut segment. All charts contain real data.</a:t>
+            </a:r>
+          </a:p>
+        </p:txBody>
+      </p:sp>
+      <p:graphicFrame>
+        <p:nvGraphicFramePr>
+          <p:cNvPr id="6" name="Chart 5"/>
+          <p:cNvGraphicFramePr>
+            <a:graphicFrameLocks noGrp="1"/>
+          </p:cNvGraphicFramePr>
+          <p:nvPr/>
+        </p:nvGraphicFramePr>
+        <p:xfrm>
+          <a:off x="548640" y="1965960"/>
+          <a:ext cx="5486400" cy="3931920"/>
+        </p:xfrm>
+        <a:graphic>
+          <a:graphicData uri="http://schemas.openxmlformats.org/drawingml/2006/chart">
+            <c:chart xmlns:c="http://schemas.openxmlformats.org/drawingml/2006/chart" r:id="rId3"/>
+          </a:graphicData>
+        </a:graphic>
+      </p:graphicFrame>
+      <p:graphicFrame>
+        <p:nvGraphicFramePr>
+          <p:cNvPr id="7" name="Chart 6"/>
+          <p:cNvGraphicFramePr>
+            <a:graphicFrameLocks noGrp="1"/>
+          </p:cNvGraphicFramePr>
+          <p:nvPr/>
+        </p:nvGraphicFramePr>
+        <p:xfrm>
+          <a:off x="6217920" y="1965960"/>
+          <a:ext cx="5394960" cy="3931920"/>
+        </p:xfrm>
+        <a:graphic>
+          <a:graphicData uri="http://schemas.openxmlformats.org/drawingml/2006/chart">
+            <c:chart xmlns:c="http://schemas.openxmlformats.org/drawingml/2006/chart" r:id="rId4"/>
+          </a:graphicData>
+        </a:graphic>
+      </p:graphicFrame>
+    </p:spTree>
+  </p:cSld>
+  <p:clrMapOvr>
+    <a:masterClrMapping/>
+  </p:clrMapOvr>
+</p:sld>
+</file>
+
+<file path=ppt/slides/slide9.xml><?xml version="1.0" encoding="utf-8"?>
+<p:sld xmlns:a="http://schemas.openxmlformats.org/drawingml/2006/main" xmlns:p="http://schemas.openxmlformats.org/presentationml/2006/main" xmlns:r="http://schemas.openxmlformats.org/officeDocument/2006/relationships">
+  <p:cSld>
+    <p:bg>
+      <p:bgPr>
+        <a:solidFill>
+          <a:srgbClr val="FFF6EF"/>
+        </a:solidFill>
+        <a:effectLst/>
+      </p:bgPr>
+    </p:bg>
+    <p:spTree>
+      <p:nvGrpSpPr>
+        <p:cNvPr id="1" name=""/>
+        <p:cNvGrpSpPr/>
+        <p:nvPr/>
+      </p:nvGrpSpPr>
+      <p:grpSpPr/>
+      <p:sp>
+        <p:nvSpPr>
+          <p:cNvPr id="2" name="Rectangle 1"/>
+          <p:cNvSpPr/>
+          <p:nvPr/>
+        </p:nvSpPr>
+        <p:spPr>
+          <a:xfrm>
+            <a:off x="0" y="0"/>
+            <a:ext cx="146304" cy="6858000"/>
+          </a:xfrm>
+          <a:prstGeom prst="rect">
+            <a:avLst/>
+          </a:prstGeom>
+          <a:solidFill>
+            <a:srgbClr val="DC623D"/>
+          </a:solidFill>
+          <a:ln>
+            <a:noFill/>
+          </a:ln>
+        </p:spPr>
+        <p:style>
+          <a:lnRef idx="1">
+            <a:schemeClr val="accent1"/>
+          </a:lnRef>
+          <a:fillRef idx="3">
+            <a:schemeClr val="accent1"/>
+          </a:fillRef>
+          <a:effectRef idx="2">
+            <a:schemeClr val="accent1"/>
+          </a:effectRef>
+          <a:fontRef idx="minor">
+            <a:schemeClr val="lt1"/>
+          </a:fontRef>
+        </p:style>
+        <p:txBody>
+          <a:bodyPr rtlCol="0" anchor="ctr"/>
+          <a:lstStyle/>
+          <a:p>
+            <a:pPr algn="ctr"/>
+          </a:p>
+        </p:txBody>
+      </p:sp>
+      <p:sp>
+        <p:nvSpPr>
+          <p:cNvPr id="3" name="TextBox 2"/>
+          <p:cNvSpPr txBox="1"/>
+          <p:nvPr/>
+        </p:nvSpPr>
+        <p:spPr>
+          <a:xfrm>
+            <a:off x="594360" y="320040"/>
+            <a:ext cx="10972800" cy="457200"/>
+          </a:xfrm>
+          <a:prstGeom prst="rect">
+            <a:avLst/>
+          </a:prstGeom>
+          <a:noFill/>
+        </p:spPr>
+        <p:txBody>
+          <a:bodyPr wrap="square">
+            <a:spAutoFit/>
+          </a:bodyPr>
+          <a:lstStyle/>
+          <a:p>
+            <a:pPr>
+              <a:defRPr sz="1200" b="1">
+                <a:solidFill>
+                  <a:srgbClr val="AC4328"/>
+                </a:solidFill>
+                <a:latin typeface="Calibri"/>
+              </a:defRPr>
+            </a:pPr>
+            <a:r>
+              <a:t>FIELD NOTES / COMMUNITY GARDEN   /   09</a:t>
+            </a:r>
+          </a:p>
+        </p:txBody>
+      </p:sp>
+      <p:sp>
+        <p:nvSpPr>
+          <p:cNvPr id="4" name="TextBox 3"/>
+          <p:cNvSpPr txBox="1"/>
+          <p:nvPr/>
+        </p:nvSpPr>
+        <p:spPr>
+          <a:xfrm>
+            <a:off x="594360" y="960120"/>
+            <a:ext cx="10972800" cy="914400"/>
+          </a:xfrm>
+          <a:prstGeom prst="rect">
+            <a:avLst/>
+          </a:prstGeom>
+          <a:noFill/>
+        </p:spPr>
+        <p:txBody>
+          <a:bodyPr wrap="square">
+            <a:spAutoFit/>
+          </a:bodyPr>
+          <a:lstStyle/>
+          <a:p>
+            <a:pPr>
+              <a:defRPr sz="3200" b="1">
+                <a:solidFill>
+                  <a:srgbClr val="192B40"/>
+                </a:solidFill>
+                <a:latin typeface="Calibri"/>
+              </a:defRPr>
+            </a:pPr>
+            <a:r>
+              <a:t>Let’s grow something good.</a:t>
+            </a:r>
+          </a:p>
+        </p:txBody>
+      </p:sp>
+      <p:sp>
+        <p:nvSpPr>
+          <p:cNvPr id="5" name="TextBox 4"/>
+          <p:cNvSpPr txBox="1"/>
+          <p:nvPr/>
+        </p:nvSpPr>
+        <p:spPr>
+          <a:xfrm>
+            <a:off x="594360" y="6263640"/>
+            <a:ext cx="10972800" cy="365760"/>
+          </a:xfrm>
+          <a:prstGeom prst="rect">
+            <a:avLst/>
+          </a:prstGeom>
+          <a:noFill/>
+        </p:spPr>
+        <p:txBody>
+          <a:bodyPr wrap="square">
+            <a:spAutoFit/>
+          </a:bodyPr>
+          <a:lstStyle/>
+          <a:p>
+            <a:pPr>
+              <a:defRPr sz="1200" b="0">
+                <a:solidFill>
+                  <a:srgbClr val="AC4328"/>
+                </a:solidFill>
+                <a:latin typeface="Calibri"/>
+              </a:defRPr>
+            </a:pPr>
+            <a:r>
+              <a:t>Try it: change the WordArt, rotate the star, or add a new slide using a different layout.</a:t>
+            </a:r>
+          </a:p>
+        </p:txBody>
+      </p:sp>
+      <p:sp>
+        <p:nvSpPr>
+          <p:cNvPr id="6" name="TextBox 5"/>
+          <p:cNvSpPr txBox="1"/>
+          <p:nvPr/>
+        </p:nvSpPr>
+        <p:spPr>
+          <a:xfrm>
+            <a:off x="640080" y="2194560"/>
+            <a:ext cx="10515600" cy="1645920"/>
+          </a:xfrm>
+          <a:prstGeom prst="rect">
+            <a:avLst/>
+          </a:prstGeom>
+          <a:noFill/>
+        </p:spPr>
+        <p:txBody>
+          <a:bodyPr wrap="square">
+            <a:spAutoFit/>
+            <a:prstTxWarp prst="textArchUp">
+              <a:avLst/>
+            </a:prstTxWarp>
+          </a:bodyPr>
+          <a:lstStyle/>
+          <a:p>
+            <a:pPr>
+              <a:defRPr sz="4800" b="1">
+                <a:solidFill>
+                  <a:srgbClr val="17644F"/>
+                </a:solidFill>
+                <a:latin typeface="Calibri"/>
+              </a:defRPr>
+            </a:pPr>
+            <a:r>
+              <a:t>GROW TOGETHER</a:t>
+            </a:r>
+          </a:p>
+        </p:txBody>
+      </p:sp>
+      <p:sp>
+        <p:nvSpPr>
+          <p:cNvPr id="7" name="5-Point Star 6"/>
+          <p:cNvSpPr/>
+          <p:nvPr/>
+        </p:nvSpPr>
+        <p:spPr>
+          <a:xfrm rot="900000">
+            <a:off x="9692640" y="4023360"/>
+            <a:ext cx="1234440" cy="1234440"/>
+          </a:xfrm>
+          <a:prstGeom prst="star5">
+            <a:avLst/>
+          </a:prstGeom>
+          <a:solidFill>
+            <a:srgbClr val="DC623D"/>
+          </a:solidFill>
+          <a:ln>
+            <a:noFill/>
+          </a:ln>
+        </p:spPr>
+        <p:style>
+          <a:lnRef idx="1">
+            <a:schemeClr val="accent1"/>
+          </a:lnRef>
+          <a:fillRef idx="3">
+            <a:schemeClr val="accent1"/>
+          </a:fillRef>
+          <a:effectRef idx="2">
+            <a:schemeClr val="accent1"/>
+          </a:effectRef>
+          <a:fontRef idx="minor">
+            <a:schemeClr val="lt1"/>
+          </a:fontRef>
+        </p:style>
+        <p:txBody>
+          <a:bodyPr rtlCol="0" anchor="ctr"/>
+          <a:lstStyle/>
+          <a:p>
+            <a:pPr algn="ctr"/>
+          </a:p>
+        </p:txBody>
+      </p:sp>
+      <p:sp>
+        <p:nvSpPr>
+          <p:cNvPr id="8" name="TextBox 7"/>
+          <p:cNvSpPr txBox="1"/>
+          <p:nvPr/>
+        </p:nvSpPr>
+        <p:spPr>
+          <a:xfrm>
+            <a:off x="731520" y="4389120"/>
+            <a:ext cx="8229600" cy="1005840"/>
+          </a:xfrm>
+          <a:prstGeom prst="rect">
+            <a:avLst/>
+          </a:prstGeom>
+          <a:noFill/>
+        </p:spPr>
+        <p:txBody>
+          <a:bodyPr wrap="square">
+            <a:spAutoFit/>
+          </a:bodyPr>
+          <a:lstStyle/>
+          <a:p>
+            <a:pPr>
+              <a:defRPr sz="2600" b="0">
+                <a:solidFill>
+                  <a:srgbClr val="192B40"/>
+                </a:solidFill>
+                <a:latin typeface="Calibri"/>
+              </a:defRPr>
+            </a:pPr>
+            <a:r>
+              <a:rPr>
+                <a:hlinkClick r:id="rId3"/>
+              </a:rPr>
               <a:t>Bring an idea. Bring a neighbor. Start here.</a:t>
             </a:r>
           </a:p>

</xml_diff>